<commit_message>
Day3 g5_heart: polish deck — fill sparse slides, brand-palette accents, speaker notes on all slides
</commit_message>
<xml_diff>
--- a/solutions/g5_heart/slides/g5_heart.pptx
+++ b/solutions/g5_heart/slides/g5_heart.pptx
@@ -7,21 +7,21 @@
   <p:sldIdLst>
     <p:sldId id="256" r:id="rId7"/>
     <p:sldId id="257" r:id="rId8"/>
-    <p:sldId id="258" r:id="rId9"/>
-    <p:sldId id="259" r:id="rId10"/>
-    <p:sldId id="260" r:id="rId11"/>
-    <p:sldId id="261" r:id="rId12"/>
-    <p:sldId id="262" r:id="rId13"/>
-    <p:sldId id="263" r:id="rId14"/>
-    <p:sldId id="264" r:id="rId15"/>
-    <p:sldId id="265" r:id="rId16"/>
-    <p:sldId id="266" r:id="rId17"/>
-    <p:sldId id="267" r:id="rId18"/>
-    <p:sldId id="268" r:id="rId19"/>
-    <p:sldId id="269" r:id="rId20"/>
-    <p:sldId id="270" r:id="rId21"/>
-    <p:sldId id="271" r:id="rId22"/>
-    <p:sldId id="272" r:id="rId23"/>
+    <p:sldId id="258" r:id="rId10"/>
+    <p:sldId id="259" r:id="rId11"/>
+    <p:sldId id="260" r:id="rId12"/>
+    <p:sldId id="261" r:id="rId13"/>
+    <p:sldId id="262" r:id="rId14"/>
+    <p:sldId id="263" r:id="rId15"/>
+    <p:sldId id="264" r:id="rId16"/>
+    <p:sldId id="265" r:id="rId17"/>
+    <p:sldId id="266" r:id="rId18"/>
+    <p:sldId id="267" r:id="rId19"/>
+    <p:sldId id="268" r:id="rId20"/>
+    <p:sldId id="269" r:id="rId21"/>
+    <p:sldId id="270" r:id="rId22"/>
+    <p:sldId id="271" r:id="rId23"/>
+    <p:sldId id="272" r:id="rId24"/>
   </p:sldIdLst>
   <p:sldSz cx="12191695" cy="6858000" type="screen4x3"/>
   <p:notesSz cx="6858000" cy="9144000"/>
@@ -121,6 +121,1571 @@
     </a:lvl9pPr>
   </p:defaultTextStyle>
 </p:presentation>
+</file>
+
+<file path=ppt/notesMasters/notesMaster1.xml><?xml version="1.0" encoding="utf-8"?>
+<p:notesMaster xmlns:a="http://schemas.openxmlformats.org/drawingml/2006/main" xmlns:p="http://schemas.openxmlformats.org/presentationml/2006/main" xmlns:r="http://schemas.openxmlformats.org/officeDocument/2006/relationships">
+  <p:cSld>
+    <p:bg>
+      <p:bgRef idx="1001">
+        <a:schemeClr val="bg1"/>
+      </p:bgRef>
+    </p:bg>
+    <p:spTree>
+      <p:nvGrpSpPr>
+        <p:cNvPr id="1" name=""/>
+        <p:cNvGrpSpPr/>
+        <p:nvPr/>
+      </p:nvGrpSpPr>
+      <p:grpSpPr>
+        <a:xfrm>
+          <a:off x="0" y="0"/>
+          <a:ext cx="0" cy="0"/>
+          <a:chOff x="0" y="0"/>
+          <a:chExt cx="0" cy="0"/>
+        </a:xfrm>
+      </p:grpSpPr>
+      <p:sp>
+        <p:nvSpPr>
+          <p:cNvPr id="2" name="Header Placeholder 1"/>
+          <p:cNvSpPr>
+            <a:spLocks noGrp="1"/>
+          </p:cNvSpPr>
+          <p:nvPr>
+            <p:ph type="hdr" sz="quarter"/>
+          </p:nvPr>
+        </p:nvSpPr>
+        <p:spPr>
+          <a:xfrm>
+            <a:off x="0" y="0"/>
+            <a:ext cx="2971800" cy="457200"/>
+          </a:xfrm>
+          <a:prstGeom prst="rect">
+            <a:avLst/>
+          </a:prstGeom>
+        </p:spPr>
+        <p:txBody>
+          <a:bodyPr vert="horz" lIns="91440" tIns="45720" rIns="91440" bIns="45720" rtlCol="0"/>
+          <a:lstStyle>
+            <a:lvl1pPr algn="l">
+              <a:defRPr sz="1200"/>
+            </a:lvl1pPr>
+          </a:lstStyle>
+          <a:p>
+            <a:endParaRPr lang="en-US"/>
+          </a:p>
+        </p:txBody>
+      </p:sp>
+      <p:sp>
+        <p:nvSpPr>
+          <p:cNvPr id="3" name="Date Placeholder 2"/>
+          <p:cNvSpPr>
+            <a:spLocks noGrp="1"/>
+          </p:cNvSpPr>
+          <p:nvPr>
+            <p:ph type="dt" idx="1"/>
+          </p:nvPr>
+        </p:nvSpPr>
+        <p:spPr>
+          <a:xfrm>
+            <a:off x="3884613" y="0"/>
+            <a:ext cx="2971800" cy="457200"/>
+          </a:xfrm>
+          <a:prstGeom prst="rect">
+            <a:avLst/>
+          </a:prstGeom>
+        </p:spPr>
+        <p:txBody>
+          <a:bodyPr vert="horz" lIns="91440" tIns="45720" rIns="91440" bIns="45720" rtlCol="0"/>
+          <a:lstStyle>
+            <a:lvl1pPr algn="r">
+              <a:defRPr sz="1200"/>
+            </a:lvl1pPr>
+          </a:lstStyle>
+          <a:p>
+            <a:fld id="{0F89C1C7-3DCD-1040-A9CF-14679D8B5DDD}" type="datetimeFigureOut">
+              <a:rPr lang="en-US" smtClean="0"/>
+              <a:t>10/17/16</a:t>
+            </a:fld>
+            <a:endParaRPr lang="en-US"/>
+          </a:p>
+        </p:txBody>
+      </p:sp>
+      <p:sp>
+        <p:nvSpPr>
+          <p:cNvPr id="4" name="Slide Image Placeholder 3"/>
+          <p:cNvSpPr>
+            <a:spLocks noGrp="1" noRot="1" noChangeAspect="1"/>
+          </p:cNvSpPr>
+          <p:nvPr>
+            <p:ph type="sldImg" idx="2"/>
+          </p:nvPr>
+        </p:nvSpPr>
+        <p:spPr>
+          <a:xfrm>
+            <a:off x="1143000" y="685800"/>
+            <a:ext cx="4572000" cy="3429000"/>
+          </a:xfrm>
+          <a:prstGeom prst="rect">
+            <a:avLst/>
+          </a:prstGeom>
+          <a:noFill/>
+          <a:ln w="12700">
+            <a:solidFill>
+              <a:prstClr val="black"/>
+            </a:solidFill>
+          </a:ln>
+        </p:spPr>
+        <p:txBody>
+          <a:bodyPr vert="horz" lIns="91440" tIns="45720" rIns="91440" bIns="45720" rtlCol="0" anchor="ctr"/>
+          <a:lstStyle/>
+          <a:p>
+            <a:endParaRPr lang="en-US"/>
+          </a:p>
+        </p:txBody>
+      </p:sp>
+      <p:sp>
+        <p:nvSpPr>
+          <p:cNvPr id="5" name="Notes Placeholder 4"/>
+          <p:cNvSpPr>
+            <a:spLocks noGrp="1"/>
+          </p:cNvSpPr>
+          <p:nvPr>
+            <p:ph type="body" sz="quarter" idx="3"/>
+          </p:nvPr>
+        </p:nvSpPr>
+        <p:spPr>
+          <a:xfrm>
+            <a:off x="685800" y="4343400"/>
+            <a:ext cx="5486400" cy="4114800"/>
+          </a:xfrm>
+          <a:prstGeom prst="rect">
+            <a:avLst/>
+          </a:prstGeom>
+        </p:spPr>
+        <p:txBody>
+          <a:bodyPr vert="horz" lIns="91440" tIns="45720" rIns="91440" bIns="45720" rtlCol="0"/>
+          <a:lstStyle/>
+          <a:p>
+            <a:pPr lvl="0"/>
+            <a:r>
+              <a:rPr lang="en-US" smtClean="0"/>
+              <a:t>Click to edit Master text styles</a:t>
+            </a:r>
+          </a:p>
+          <a:p>
+            <a:pPr lvl="1"/>
+            <a:r>
+              <a:rPr lang="en-US" smtClean="0"/>
+              <a:t>Second level</a:t>
+            </a:r>
+          </a:p>
+          <a:p>
+            <a:pPr lvl="2"/>
+            <a:r>
+              <a:rPr lang="en-US" smtClean="0"/>
+              <a:t>Third level</a:t>
+            </a:r>
+          </a:p>
+          <a:p>
+            <a:pPr lvl="3"/>
+            <a:r>
+              <a:rPr lang="en-US" smtClean="0"/>
+              <a:t>Fourth level</a:t>
+            </a:r>
+          </a:p>
+          <a:p>
+            <a:pPr lvl="4"/>
+            <a:r>
+              <a:rPr lang="en-US" smtClean="0"/>
+              <a:t>Fifth level</a:t>
+            </a:r>
+            <a:endParaRPr lang="en-US"/>
+          </a:p>
+        </p:txBody>
+      </p:sp>
+      <p:sp>
+        <p:nvSpPr>
+          <p:cNvPr id="6" name="Footer Placeholder 5"/>
+          <p:cNvSpPr>
+            <a:spLocks noGrp="1"/>
+          </p:cNvSpPr>
+          <p:nvPr>
+            <p:ph type="ftr" sz="quarter" idx="4"/>
+          </p:nvPr>
+        </p:nvSpPr>
+        <p:spPr>
+          <a:xfrm>
+            <a:off x="0" y="8685213"/>
+            <a:ext cx="2971800" cy="457200"/>
+          </a:xfrm>
+          <a:prstGeom prst="rect">
+            <a:avLst/>
+          </a:prstGeom>
+        </p:spPr>
+        <p:txBody>
+          <a:bodyPr vert="horz" lIns="91440" tIns="45720" rIns="91440" bIns="45720" rtlCol="0" anchor="b"/>
+          <a:lstStyle>
+            <a:lvl1pPr algn="l">
+              <a:defRPr sz="1200"/>
+            </a:lvl1pPr>
+          </a:lstStyle>
+          <a:p>
+            <a:endParaRPr lang="en-US"/>
+          </a:p>
+        </p:txBody>
+      </p:sp>
+      <p:sp>
+        <p:nvSpPr>
+          <p:cNvPr id="7" name="Slide Number Placeholder 6"/>
+          <p:cNvSpPr>
+            <a:spLocks noGrp="1"/>
+          </p:cNvSpPr>
+          <p:nvPr>
+            <p:ph type="sldNum" sz="quarter" idx="5"/>
+          </p:nvPr>
+        </p:nvSpPr>
+        <p:spPr>
+          <a:xfrm>
+            <a:off x="3884613" y="8685213"/>
+            <a:ext cx="2971800" cy="457200"/>
+          </a:xfrm>
+          <a:prstGeom prst="rect">
+            <a:avLst/>
+          </a:prstGeom>
+        </p:spPr>
+        <p:txBody>
+          <a:bodyPr vert="horz" lIns="91440" tIns="45720" rIns="91440" bIns="45720" rtlCol="0" anchor="b"/>
+          <a:lstStyle>
+            <a:lvl1pPr algn="r">
+              <a:defRPr sz="1200"/>
+            </a:lvl1pPr>
+          </a:lstStyle>
+          <a:p>
+            <a:fld id="{BB5E49A5-4136-284D-997B-48E1D791AD67}" type="slidenum">
+              <a:rPr lang="en-US" smtClean="0"/>
+              <a:t>‹#›</a:t>
+            </a:fld>
+            <a:endParaRPr lang="en-US"/>
+          </a:p>
+        </p:txBody>
+      </p:sp>
+    </p:spTree>
+    <p:extLst>
+      <p:ext uri="{BB962C8B-B14F-4D97-AF65-F5344CB8AC3E}">
+        <p14:creationId xmlns:p14="http://schemas.microsoft.com/office/powerpoint/2010/main" val="2623252185"/>
+      </p:ext>
+    </p:extLst>
+  </p:cSld>
+  <p:clrMap bg1="lt1" tx1="dk1" bg2="lt2" tx2="dk2" accent1="accent1" accent2="accent2" accent3="accent3" accent4="accent4" accent5="accent5" accent6="accent6" hlink="hlink" folHlink="folHlink"/>
+  <p:notesStyle>
+    <a:lvl1pPr marL="0" algn="l" defTabSz="457200" rtl="0" eaLnBrk="1" latinLnBrk="0" hangingPunct="1">
+      <a:defRPr sz="1200" kern="1200">
+        <a:solidFill>
+          <a:schemeClr val="tx1"/>
+        </a:solidFill>
+        <a:latin typeface="+mn-lt"/>
+        <a:ea typeface="+mn-ea"/>
+        <a:cs typeface="+mn-cs"/>
+      </a:defRPr>
+    </a:lvl1pPr>
+    <a:lvl2pPr marL="457200" algn="l" defTabSz="457200" rtl="0" eaLnBrk="1" latinLnBrk="0" hangingPunct="1">
+      <a:defRPr sz="1200" kern="1200">
+        <a:solidFill>
+          <a:schemeClr val="tx1"/>
+        </a:solidFill>
+        <a:latin typeface="+mn-lt"/>
+        <a:ea typeface="+mn-ea"/>
+        <a:cs typeface="+mn-cs"/>
+      </a:defRPr>
+    </a:lvl2pPr>
+    <a:lvl3pPr marL="914400" algn="l" defTabSz="457200" rtl="0" eaLnBrk="1" latinLnBrk="0" hangingPunct="1">
+      <a:defRPr sz="1200" kern="1200">
+        <a:solidFill>
+          <a:schemeClr val="tx1"/>
+        </a:solidFill>
+        <a:latin typeface="+mn-lt"/>
+        <a:ea typeface="+mn-ea"/>
+        <a:cs typeface="+mn-cs"/>
+      </a:defRPr>
+    </a:lvl3pPr>
+    <a:lvl4pPr marL="1371600" algn="l" defTabSz="457200" rtl="0" eaLnBrk="1" latinLnBrk="0" hangingPunct="1">
+      <a:defRPr sz="1200" kern="1200">
+        <a:solidFill>
+          <a:schemeClr val="tx1"/>
+        </a:solidFill>
+        <a:latin typeface="+mn-lt"/>
+        <a:ea typeface="+mn-ea"/>
+        <a:cs typeface="+mn-cs"/>
+      </a:defRPr>
+    </a:lvl4pPr>
+    <a:lvl5pPr marL="1828800" algn="l" defTabSz="457200" rtl="0" eaLnBrk="1" latinLnBrk="0" hangingPunct="1">
+      <a:defRPr sz="1200" kern="1200">
+        <a:solidFill>
+          <a:schemeClr val="tx1"/>
+        </a:solidFill>
+        <a:latin typeface="+mn-lt"/>
+        <a:ea typeface="+mn-ea"/>
+        <a:cs typeface="+mn-cs"/>
+      </a:defRPr>
+    </a:lvl5pPr>
+    <a:lvl6pPr marL="2286000" algn="l" defTabSz="457200" rtl="0" eaLnBrk="1" latinLnBrk="0" hangingPunct="1">
+      <a:defRPr sz="1200" kern="1200">
+        <a:solidFill>
+          <a:schemeClr val="tx1"/>
+        </a:solidFill>
+        <a:latin typeface="+mn-lt"/>
+        <a:ea typeface="+mn-ea"/>
+        <a:cs typeface="+mn-cs"/>
+      </a:defRPr>
+    </a:lvl6pPr>
+    <a:lvl7pPr marL="2743200" algn="l" defTabSz="457200" rtl="0" eaLnBrk="1" latinLnBrk="0" hangingPunct="1">
+      <a:defRPr sz="1200" kern="1200">
+        <a:solidFill>
+          <a:schemeClr val="tx1"/>
+        </a:solidFill>
+        <a:latin typeface="+mn-lt"/>
+        <a:ea typeface="+mn-ea"/>
+        <a:cs typeface="+mn-cs"/>
+      </a:defRPr>
+    </a:lvl7pPr>
+    <a:lvl8pPr marL="3200400" algn="l" defTabSz="457200" rtl="0" eaLnBrk="1" latinLnBrk="0" hangingPunct="1">
+      <a:defRPr sz="1200" kern="1200">
+        <a:solidFill>
+          <a:schemeClr val="tx1"/>
+        </a:solidFill>
+        <a:latin typeface="+mn-lt"/>
+        <a:ea typeface="+mn-ea"/>
+        <a:cs typeface="+mn-cs"/>
+      </a:defRPr>
+    </a:lvl8pPr>
+    <a:lvl9pPr marL="3657600" algn="l" defTabSz="457200" rtl="0" eaLnBrk="1" latinLnBrk="0" hangingPunct="1">
+      <a:defRPr sz="1200" kern="1200">
+        <a:solidFill>
+          <a:schemeClr val="tx1"/>
+        </a:solidFill>
+        <a:latin typeface="+mn-lt"/>
+        <a:ea typeface="+mn-ea"/>
+        <a:cs typeface="+mn-cs"/>
+      </a:defRPr>
+    </a:lvl9pPr>
+  </p:notesStyle>
+</p:notesMaster>
+</file>
+
+<file path=ppt/notesSlides/notesSlide1.xml><?xml version="1.0" encoding="utf-8"?>
+<p:notes xmlns:a="http://schemas.openxmlformats.org/drawingml/2006/main" xmlns:p="http://schemas.openxmlformats.org/presentationml/2006/main" xmlns:r="http://schemas.openxmlformats.org/officeDocument/2006/relationships">
+  <p:cSld>
+    <p:spTree>
+      <p:nvGrpSpPr>
+        <p:cNvPr id="1" name=""/>
+        <p:cNvGrpSpPr/>
+        <p:nvPr/>
+      </p:nvGrpSpPr>
+      <p:grpSpPr>
+        <a:xfrm>
+          <a:off x="0" y="0"/>
+          <a:ext cx="0" cy="0"/>
+          <a:chOff x="0" y="0"/>
+          <a:chExt cx="0" cy="0"/>
+        </a:xfrm>
+      </p:grpSpPr>
+      <p:sp>
+        <p:nvSpPr>
+          <p:cNvPr id="2" name="Slide Image Placeholder 1"/>
+          <p:cNvSpPr>
+            <a:spLocks noGrp="1"/>
+          </p:cNvSpPr>
+          <p:nvPr>
+            <p:ph type="sldImg" idx="2"/>
+          </p:nvPr>
+        </p:nvSpPr>
+        <p:spPr/>
+      </p:sp>
+      <p:sp>
+        <p:nvSpPr>
+          <p:cNvPr id="3" name="Notes Placeholder 2"/>
+          <p:cNvSpPr>
+            <a:spLocks noGrp="1"/>
+          </p:cNvSpPr>
+          <p:nvPr>
+            <p:ph type="body" idx="3" sz="quarter"/>
+          </p:nvPr>
+        </p:nvSpPr>
+        <p:spPr/>
+        <p:txBody>
+          <a:bodyPr/>
+          <a:lstStyle/>
+          <a:p>
+            <a:r>
+              <a:rPr b="1" sz="1300">
+                <a:latin typeface="Geist Mono"/>
+              </a:rPr>
+              <a:t>Background</a:t>
+            </a:r>
+          </a:p>
+          <a:p>
+            <a:r>
+              <a:rPr b="0" sz="1100">
+                <a:latin typeface="Geist"/>
+              </a:rPr>
+              <a:t>This first section sets up the medical problem before any code. Two facts matter: heart risk is built from many measurements at once, and women's heart disease is systematically missed. Both will shape how we read our model later.</a:t>
+            </a:r>
+          </a:p>
+        </p:txBody>
+      </p:sp>
+      <p:sp>
+        <p:nvSpPr>
+          <p:cNvPr id="4" name="Slide Number Placeholder 3"/>
+          <p:cNvSpPr>
+            <a:spLocks noGrp="1"/>
+          </p:cNvSpPr>
+          <p:nvPr>
+            <p:ph type="sldNum" idx="5" sz="quarter"/>
+          </p:nvPr>
+        </p:nvSpPr>
+        <p:spPr/>
+      </p:sp>
+    </p:spTree>
+  </p:cSld>
+  <p:clrMapOvr>
+    <a:masterClrMapping/>
+  </p:clrMapOvr>
+</p:notes>
+</file>
+
+<file path=ppt/notesSlides/notesSlide10.xml><?xml version="1.0" encoding="utf-8"?>
+<p:notes xmlns:a="http://schemas.openxmlformats.org/drawingml/2006/main" xmlns:p="http://schemas.openxmlformats.org/presentationml/2006/main" xmlns:r="http://schemas.openxmlformats.org/officeDocument/2006/relationships">
+  <p:cSld>
+    <p:spTree>
+      <p:nvGrpSpPr>
+        <p:cNvPr id="1" name=""/>
+        <p:cNvGrpSpPr/>
+        <p:nvPr/>
+      </p:nvGrpSpPr>
+      <p:grpSpPr>
+        <a:xfrm>
+          <a:off x="0" y="0"/>
+          <a:ext cx="0" cy="0"/>
+          <a:chOff x="0" y="0"/>
+          <a:chExt cx="0" cy="0"/>
+        </a:xfrm>
+      </p:grpSpPr>
+      <p:sp>
+        <p:nvSpPr>
+          <p:cNvPr id="2" name="Slide Image Placeholder 1"/>
+          <p:cNvSpPr>
+            <a:spLocks noGrp="1"/>
+          </p:cNvSpPr>
+          <p:nvPr>
+            <p:ph type="sldImg" idx="2"/>
+          </p:nvPr>
+        </p:nvSpPr>
+        <p:spPr/>
+      </p:sp>
+      <p:sp>
+        <p:nvSpPr>
+          <p:cNvPr id="3" name="Notes Placeholder 2"/>
+          <p:cNvSpPr>
+            <a:spLocks noGrp="1"/>
+          </p:cNvSpPr>
+          <p:nvPr>
+            <p:ph type="body" idx="3" sz="quarter"/>
+          </p:nvPr>
+        </p:nvSpPr>
+        <p:spPr/>
+        <p:txBody>
+          <a:bodyPr/>
+          <a:lstStyle/>
+          <a:p>
+            <a:r>
+              <a:rPr b="1" sz="1300">
+                <a:latin typeface="Geist Mono"/>
+              </a:rPr>
+              <a:t>Accurate overall, but not equally by sex</a:t>
+            </a:r>
+          </a:p>
+          <a:p>
+            <a:r>
+              <a:rPr b="0" sz="1100">
+                <a:latin typeface="Geist"/>
+              </a:rPr>
+              <a:t>This is the heart of the project. A single accuracy number looked fine, but grading women and men separately reveals about a nine-point gap. The point is not the direction of the gap -- it is that you only discover unfairness when you deliberately look for it.</a:t>
+            </a:r>
+          </a:p>
+        </p:txBody>
+      </p:sp>
+      <p:sp>
+        <p:nvSpPr>
+          <p:cNvPr id="4" name="Slide Number Placeholder 3"/>
+          <p:cNvSpPr>
+            <a:spLocks noGrp="1"/>
+          </p:cNvSpPr>
+          <p:nvPr>
+            <p:ph type="sldNum" idx="5" sz="quarter"/>
+          </p:nvPr>
+        </p:nvSpPr>
+        <p:spPr/>
+      </p:sp>
+    </p:spTree>
+  </p:cSld>
+  <p:clrMapOvr>
+    <a:masterClrMapping/>
+  </p:clrMapOvr>
+</p:notes>
+</file>
+
+<file path=ppt/notesSlides/notesSlide11.xml><?xml version="1.0" encoding="utf-8"?>
+<p:notes xmlns:a="http://schemas.openxmlformats.org/drawingml/2006/main" xmlns:p="http://schemas.openxmlformats.org/presentationml/2006/main" xmlns:r="http://schemas.openxmlformats.org/officeDocument/2006/relationships">
+  <p:cSld>
+    <p:spTree>
+      <p:nvGrpSpPr>
+        <p:cNvPr id="1" name=""/>
+        <p:cNvGrpSpPr/>
+        <p:nvPr/>
+      </p:nvGrpSpPr>
+      <p:grpSpPr>
+        <a:xfrm>
+          <a:off x="0" y="0"/>
+          <a:ext cx="0" cy="0"/>
+          <a:chOff x="0" y="0"/>
+          <a:chExt cx="0" cy="0"/>
+        </a:xfrm>
+      </p:grpSpPr>
+      <p:sp>
+        <p:nvSpPr>
+          <p:cNvPr id="2" name="Slide Image Placeholder 1"/>
+          <p:cNvSpPr>
+            <a:spLocks noGrp="1"/>
+          </p:cNvSpPr>
+          <p:nvPr>
+            <p:ph type="sldImg" idx="2"/>
+          </p:nvPr>
+        </p:nvSpPr>
+        <p:spPr/>
+      </p:sp>
+      <p:sp>
+        <p:nvSpPr>
+          <p:cNvPr id="3" name="Notes Placeholder 2"/>
+          <p:cNvSpPr>
+            <a:spLocks noGrp="1"/>
+          </p:cNvSpPr>
+          <p:nvPr>
+            <p:ph type="body" idx="3" sz="quarter"/>
+          </p:nvPr>
+        </p:nvSpPr>
+        <p:spPr/>
+        <p:txBody>
+          <a:bodyPr/>
+          <a:lstStyle/>
+          <a:p>
+            <a:r>
+              <a:rPr b="1" sz="1300">
+                <a:latin typeface="Geist Mono"/>
+              </a:rPr>
+              <a:t>Being honest</a:t>
+            </a:r>
+          </a:p>
+          <a:p>
+            <a:r>
+              <a:rPr b="0" sz="1100">
+                <a:latin typeface="Geist"/>
+              </a:rPr>
+              <a:t>Good medical-AI work states loudly what it cannot claim. This section covers where our result comes from -- a small, skewed, decades-old dataset -- and what we are and are not allowed to conclude from it.</a:t>
+            </a:r>
+          </a:p>
+        </p:txBody>
+      </p:sp>
+      <p:sp>
+        <p:nvSpPr>
+          <p:cNvPr id="4" name="Slide Number Placeholder 3"/>
+          <p:cNvSpPr>
+            <a:spLocks noGrp="1"/>
+          </p:cNvSpPr>
+          <p:nvPr>
+            <p:ph type="sldNum" idx="5" sz="quarter"/>
+          </p:nvPr>
+        </p:nvSpPr>
+        <p:spPr/>
+      </p:sp>
+    </p:spTree>
+  </p:cSld>
+  <p:clrMapOvr>
+    <a:masterClrMapping/>
+  </p:clrMapOvr>
+</p:notes>
+</file>
+
+<file path=ppt/notesSlides/notesSlide12.xml><?xml version="1.0" encoding="utf-8"?>
+<p:notes xmlns:a="http://schemas.openxmlformats.org/drawingml/2006/main" xmlns:p="http://schemas.openxmlformats.org/presentationml/2006/main" xmlns:r="http://schemas.openxmlformats.org/officeDocument/2006/relationships">
+  <p:cSld>
+    <p:spTree>
+      <p:nvGrpSpPr>
+        <p:cNvPr id="1" name=""/>
+        <p:cNvGrpSpPr/>
+        <p:nvPr/>
+      </p:nvGrpSpPr>
+      <p:grpSpPr>
+        <a:xfrm>
+          <a:off x="0" y="0"/>
+          <a:ext cx="0" cy="0"/>
+          <a:chOff x="0" y="0"/>
+          <a:chExt cx="0" cy="0"/>
+        </a:xfrm>
+      </p:grpSpPr>
+      <p:sp>
+        <p:nvSpPr>
+          <p:cNvPr id="2" name="Slide Image Placeholder 1"/>
+          <p:cNvSpPr>
+            <a:spLocks noGrp="1"/>
+          </p:cNvSpPr>
+          <p:nvPr>
+            <p:ph type="sldImg" idx="2"/>
+          </p:nvPr>
+        </p:nvSpPr>
+        <p:spPr/>
+      </p:sp>
+      <p:sp>
+        <p:nvSpPr>
+          <p:cNvPr id="3" name="Notes Placeholder 2"/>
+          <p:cNvSpPr>
+            <a:spLocks noGrp="1"/>
+          </p:cNvSpPr>
+          <p:nvPr>
+            <p:ph type="body" idx="3" sz="quarter"/>
+          </p:nvPr>
+        </p:nvSpPr>
+        <p:spPr/>
+        <p:txBody>
+          <a:bodyPr/>
+          <a:lstStyle/>
+          <a:p>
+            <a:r>
+              <a:rPr b="1" sz="1300">
+                <a:latin typeface="Geist Mono"/>
+              </a:rPr>
+              <a:t>The data is small and male-skewed</a:t>
+            </a:r>
+          </a:p>
+          <a:p>
+            <a:r>
+              <a:rPr b="0" sz="1100">
+                <a:latin typeface="Geist"/>
+              </a:rPr>
+              <a:t>Our data is about two men for every woman, so the model simply gets less practice on women. That skew is not a bug we can code away -- it is baked into how the 1980s study was collected, and it mirrors the same real-world bias that makes women's heart disease harder to catch. Every result above must be read through this limitation.</a:t>
+            </a:r>
+          </a:p>
+        </p:txBody>
+      </p:sp>
+      <p:sp>
+        <p:nvSpPr>
+          <p:cNvPr id="4" name="Slide Number Placeholder 3"/>
+          <p:cNvSpPr>
+            <a:spLocks noGrp="1"/>
+          </p:cNvSpPr>
+          <p:nvPr>
+            <p:ph type="sldNum" idx="5" sz="quarter"/>
+          </p:nvPr>
+        </p:nvSpPr>
+        <p:spPr/>
+      </p:sp>
+    </p:spTree>
+  </p:cSld>
+  <p:clrMapOvr>
+    <a:masterClrMapping/>
+  </p:clrMapOvr>
+</p:notes>
+</file>
+
+<file path=ppt/notesSlides/notesSlide13.xml><?xml version="1.0" encoding="utf-8"?>
+<p:notes xmlns:a="http://schemas.openxmlformats.org/drawingml/2006/main" xmlns:p="http://schemas.openxmlformats.org/presentationml/2006/main" xmlns:r="http://schemas.openxmlformats.org/officeDocument/2006/relationships">
+  <p:cSld>
+    <p:spTree>
+      <p:nvGrpSpPr>
+        <p:cNvPr id="1" name=""/>
+        <p:cNvGrpSpPr/>
+        <p:nvPr/>
+      </p:nvGrpSpPr>
+      <p:grpSpPr>
+        <a:xfrm>
+          <a:off x="0" y="0"/>
+          <a:ext cx="0" cy="0"/>
+          <a:chOff x="0" y="0"/>
+          <a:chExt cx="0" cy="0"/>
+        </a:xfrm>
+      </p:grpSpPr>
+      <p:sp>
+        <p:nvSpPr>
+          <p:cNvPr id="2" name="Slide Image Placeholder 1"/>
+          <p:cNvSpPr>
+            <a:spLocks noGrp="1"/>
+          </p:cNvSpPr>
+          <p:nvPr>
+            <p:ph type="sldImg" idx="2"/>
+          </p:nvPr>
+        </p:nvSpPr>
+        <p:spPr/>
+      </p:sp>
+      <p:sp>
+        <p:nvSpPr>
+          <p:cNvPr id="3" name="Notes Placeholder 2"/>
+          <p:cNvSpPr>
+            <a:spLocks noGrp="1"/>
+          </p:cNvSpPr>
+          <p:nvPr>
+            <p:ph type="body" idx="3" sz="quarter"/>
+          </p:nvPr>
+        </p:nvSpPr>
+        <p:spPr/>
+        <p:txBody>
+          <a:bodyPr/>
+          <a:lstStyle/>
+          <a:p>
+            <a:r>
+              <a:rPr b="1" sz="1300">
+                <a:latin typeface="Geist Mono"/>
+              </a:rPr>
+              <a:t>What this project can and cannot say</a:t>
+            </a:r>
+          </a:p>
+          <a:p>
+            <a:r>
+              <a:rPr b="0" sz="1100">
+                <a:latin typeface="Geist"/>
+              </a:rPr>
+              <a:t>This is the most important slide in any medical-AI talk. Our toy model earns the right to say checkup features carry signal, no single number is the whole story, and accuracy can be unequal -- but it cannot say anything trustworthy about today's patients. And in a real tool, missing a heart attack is far worse than a false alarm, so you would tune for sensitivity, not raw accuracy.</a:t>
+            </a:r>
+          </a:p>
+        </p:txBody>
+      </p:sp>
+      <p:sp>
+        <p:nvSpPr>
+          <p:cNvPr id="4" name="Slide Number Placeholder 3"/>
+          <p:cNvSpPr>
+            <a:spLocks noGrp="1"/>
+          </p:cNvSpPr>
+          <p:nvPr>
+            <p:ph type="sldNum" idx="5" sz="quarter"/>
+          </p:nvPr>
+        </p:nvSpPr>
+        <p:spPr/>
+      </p:sp>
+    </p:spTree>
+  </p:cSld>
+  <p:clrMapOvr>
+    <a:masterClrMapping/>
+  </p:clrMapOvr>
+</p:notes>
+</file>
+
+<file path=ppt/notesSlides/notesSlide14.xml><?xml version="1.0" encoding="utf-8"?>
+<p:notes xmlns:a="http://schemas.openxmlformats.org/drawingml/2006/main" xmlns:p="http://schemas.openxmlformats.org/presentationml/2006/main" xmlns:r="http://schemas.openxmlformats.org/officeDocument/2006/relationships">
+  <p:cSld>
+    <p:spTree>
+      <p:nvGrpSpPr>
+        <p:cNvPr id="1" name=""/>
+        <p:cNvGrpSpPr/>
+        <p:nvPr/>
+      </p:nvGrpSpPr>
+      <p:grpSpPr>
+        <a:xfrm>
+          <a:off x="0" y="0"/>
+          <a:ext cx="0" cy="0"/>
+          <a:chOff x="0" y="0"/>
+          <a:chExt cx="0" cy="0"/>
+        </a:xfrm>
+      </p:grpSpPr>
+      <p:sp>
+        <p:nvSpPr>
+          <p:cNvPr id="2" name="Slide Image Placeholder 1"/>
+          <p:cNvSpPr>
+            <a:spLocks noGrp="1"/>
+          </p:cNvSpPr>
+          <p:nvPr>
+            <p:ph type="sldImg" idx="2"/>
+          </p:nvPr>
+        </p:nvSpPr>
+        <p:spPr/>
+      </p:sp>
+      <p:sp>
+        <p:nvSpPr>
+          <p:cNvPr id="3" name="Notes Placeholder 2"/>
+          <p:cNvSpPr>
+            <a:spLocks noGrp="1"/>
+          </p:cNvSpPr>
+          <p:nvPr>
+            <p:ph type="body" idx="3" sz="quarter"/>
+          </p:nvPr>
+        </p:nvSpPr>
+        <p:spPr/>
+        <p:txBody>
+          <a:bodyPr/>
+          <a:lstStyle/>
+          <a:p>
+            <a:r>
+              <a:rPr b="1" sz="1300">
+                <a:latin typeface="Geist Mono"/>
+              </a:rPr>
+              <a:t>References</a:t>
+            </a:r>
+          </a:p>
+          <a:p>
+            <a:r>
+              <a:rPr b="0" sz="1100">
+                <a:latin typeface="Geist"/>
+              </a:rPr>
+              <a:t>Every claim in this deck traces to a peer-reviewed source. These are the papers behind the risk factors, the under-diagnosis of women, and the dataset itself.</a:t>
+            </a:r>
+          </a:p>
+        </p:txBody>
+      </p:sp>
+      <p:sp>
+        <p:nvSpPr>
+          <p:cNvPr id="4" name="Slide Number Placeholder 3"/>
+          <p:cNvSpPr>
+            <a:spLocks noGrp="1"/>
+          </p:cNvSpPr>
+          <p:nvPr>
+            <p:ph type="sldNum" idx="5" sz="quarter"/>
+          </p:nvPr>
+        </p:nvSpPr>
+        <p:spPr/>
+      </p:sp>
+    </p:spTree>
+  </p:cSld>
+  <p:clrMapOvr>
+    <a:masterClrMapping/>
+  </p:clrMapOvr>
+</p:notes>
+</file>
+
+<file path=ppt/notesSlides/notesSlide15.xml><?xml version="1.0" encoding="utf-8"?>
+<p:notes xmlns:a="http://schemas.openxmlformats.org/drawingml/2006/main" xmlns:p="http://schemas.openxmlformats.org/presentationml/2006/main" xmlns:r="http://schemas.openxmlformats.org/officeDocument/2006/relationships">
+  <p:cSld>
+    <p:spTree>
+      <p:nvGrpSpPr>
+        <p:cNvPr id="1" name=""/>
+        <p:cNvGrpSpPr/>
+        <p:nvPr/>
+      </p:nvGrpSpPr>
+      <p:grpSpPr>
+        <a:xfrm>
+          <a:off x="0" y="0"/>
+          <a:ext cx="0" cy="0"/>
+          <a:chOff x="0" y="0"/>
+          <a:chExt cx="0" cy="0"/>
+        </a:xfrm>
+      </p:grpSpPr>
+      <p:sp>
+        <p:nvSpPr>
+          <p:cNvPr id="2" name="Slide Image Placeholder 1"/>
+          <p:cNvSpPr>
+            <a:spLocks noGrp="1"/>
+          </p:cNvSpPr>
+          <p:nvPr>
+            <p:ph type="sldImg" idx="2"/>
+          </p:nvPr>
+        </p:nvSpPr>
+        <p:spPr/>
+      </p:sp>
+      <p:sp>
+        <p:nvSpPr>
+          <p:cNvPr id="3" name="Notes Placeholder 2"/>
+          <p:cNvSpPr>
+            <a:spLocks noGrp="1"/>
+          </p:cNvSpPr>
+          <p:nvPr>
+            <p:ph type="body" idx="3" sz="quarter"/>
+          </p:nvPr>
+        </p:nvSpPr>
+        <p:spPr/>
+        <p:txBody>
+          <a:bodyPr/>
+          <a:lstStyle/>
+          <a:p>
+            <a:r>
+              <a:rPr b="1" sz="1300">
+                <a:latin typeface="Geist Mono"/>
+              </a:rPr>
+              <a:t>Sources</a:t>
+            </a:r>
+          </a:p>
+          <a:p>
+            <a:r>
+              <a:rPr b="0" sz="1100">
+                <a:latin typeface="Geist"/>
+              </a:rPr>
+              <a:t>These are the primary references. The risk-scoring and INTERHEART work back the 'stack of factors' framing; the AHA statement and its follow-ups document the under-diagnosis of women; and Detrano 1989 is the origin of the Cleveland dataset we used.</a:t>
+            </a:r>
+          </a:p>
+        </p:txBody>
+      </p:sp>
+      <p:sp>
+        <p:nvSpPr>
+          <p:cNvPr id="4" name="Slide Number Placeholder 3"/>
+          <p:cNvSpPr>
+            <a:spLocks noGrp="1"/>
+          </p:cNvSpPr>
+          <p:nvPr>
+            <p:ph type="sldNum" idx="5" sz="quarter"/>
+          </p:nvPr>
+        </p:nvSpPr>
+        <p:spPr/>
+      </p:sp>
+    </p:spTree>
+  </p:cSld>
+  <p:clrMapOvr>
+    <a:masterClrMapping/>
+  </p:clrMapOvr>
+</p:notes>
+</file>
+
+<file path=ppt/notesSlides/notesSlide2.xml><?xml version="1.0" encoding="utf-8"?>
+<p:notes xmlns:a="http://schemas.openxmlformats.org/drawingml/2006/main" xmlns:p="http://schemas.openxmlformats.org/presentationml/2006/main" xmlns:r="http://schemas.openxmlformats.org/officeDocument/2006/relationships">
+  <p:cSld>
+    <p:spTree>
+      <p:nvGrpSpPr>
+        <p:cNvPr id="1" name=""/>
+        <p:cNvGrpSpPr/>
+        <p:nvPr/>
+      </p:nvGrpSpPr>
+      <p:grpSpPr>
+        <a:xfrm>
+          <a:off x="0" y="0"/>
+          <a:ext cx="0" cy="0"/>
+          <a:chOff x="0" y="0"/>
+          <a:chExt cx="0" cy="0"/>
+        </a:xfrm>
+      </p:grpSpPr>
+      <p:sp>
+        <p:nvSpPr>
+          <p:cNvPr id="2" name="Slide Image Placeholder 1"/>
+          <p:cNvSpPr>
+            <a:spLocks noGrp="1"/>
+          </p:cNvSpPr>
+          <p:nvPr>
+            <p:ph type="sldImg" idx="2"/>
+          </p:nvPr>
+        </p:nvSpPr>
+        <p:spPr/>
+      </p:sp>
+      <p:sp>
+        <p:nvSpPr>
+          <p:cNvPr id="3" name="Notes Placeholder 2"/>
+          <p:cNvSpPr>
+            <a:spLocks noGrp="1"/>
+          </p:cNvSpPr>
+          <p:nvPr>
+            <p:ph type="body" idx="3" sz="quarter"/>
+          </p:nvPr>
+        </p:nvSpPr>
+        <p:spPr/>
+        <p:txBody>
+          <a:bodyPr/>
+          <a:lstStyle/>
+          <a:p>
+            <a:r>
+              <a:rPr b="1" sz="1300">
+                <a:latin typeface="Geist Mono"/>
+              </a:rPr>
+              <a:t>How doctors actually estimate heart risk</a:t>
+            </a:r>
+          </a:p>
+          <a:p>
+            <a:r>
+              <a:rPr b="0" sz="1100">
+                <a:latin typeface="Geist"/>
+              </a:rPr>
+              <a:t>The takeaway is that no single measurement decides heart risk -- doctors add up many factors, the way the Framingham score does. The bars show how much each factor multiplies risk; cholesterol and smoking lead, but none acts alone. Hold this 'stack of factors' idea for when we test cholesterol by itself.</a:t>
+            </a:r>
+          </a:p>
+        </p:txBody>
+      </p:sp>
+      <p:sp>
+        <p:nvSpPr>
+          <p:cNvPr id="4" name="Slide Number Placeholder 3"/>
+          <p:cNvSpPr>
+            <a:spLocks noGrp="1"/>
+          </p:cNvSpPr>
+          <p:nvPr>
+            <p:ph type="sldNum" idx="5" sz="quarter"/>
+          </p:nvPr>
+        </p:nvSpPr>
+        <p:spPr/>
+      </p:sp>
+    </p:spTree>
+  </p:cSld>
+  <p:clrMapOvr>
+    <a:masterClrMapping/>
+  </p:clrMapOvr>
+</p:notes>
+</file>
+
+<file path=ppt/notesSlides/notesSlide3.xml><?xml version="1.0" encoding="utf-8"?>
+<p:notes xmlns:a="http://schemas.openxmlformats.org/drawingml/2006/main" xmlns:p="http://schemas.openxmlformats.org/presentationml/2006/main" xmlns:r="http://schemas.openxmlformats.org/officeDocument/2006/relationships">
+  <p:cSld>
+    <p:spTree>
+      <p:nvGrpSpPr>
+        <p:cNvPr id="1" name=""/>
+        <p:cNvGrpSpPr/>
+        <p:nvPr/>
+      </p:nvGrpSpPr>
+      <p:grpSpPr>
+        <a:xfrm>
+          <a:off x="0" y="0"/>
+          <a:ext cx="0" cy="0"/>
+          <a:chOff x="0" y="0"/>
+          <a:chExt cx="0" cy="0"/>
+        </a:xfrm>
+      </p:grpSpPr>
+      <p:sp>
+        <p:nvSpPr>
+          <p:cNvPr id="2" name="Slide Image Placeholder 1"/>
+          <p:cNvSpPr>
+            <a:spLocks noGrp="1"/>
+          </p:cNvSpPr>
+          <p:nvPr>
+            <p:ph type="sldImg" idx="2"/>
+          </p:nvPr>
+        </p:nvSpPr>
+        <p:spPr/>
+      </p:sp>
+      <p:sp>
+        <p:nvSpPr>
+          <p:cNvPr id="3" name="Notes Placeholder 2"/>
+          <p:cNvSpPr>
+            <a:spLocks noGrp="1"/>
+          </p:cNvSpPr>
+          <p:nvPr>
+            <p:ph type="body" idx="3" sz="quarter"/>
+          </p:nvPr>
+        </p:nvSpPr>
+        <p:spPr/>
+        <p:txBody>
+          <a:bodyPr/>
+          <a:lstStyle/>
+          <a:p>
+            <a:r>
+              <a:rPr b="1" sz="1300">
+                <a:latin typeface="Geist Mono"/>
+              </a:rPr>
+              <a:t>Women’s heart disease is under-diagnosed</a:t>
+            </a:r>
+          </a:p>
+          <a:p>
+            <a:r>
+              <a:rPr b="0" sz="1100">
+                <a:latin typeface="Geist"/>
+              </a:rPr>
+              <a:t>This slide is the motivation for the whole project. The classic chest-pain picture is the male one, so women's often different symptoms get missed, and the AHA has documented that women are under-diagnosed and under-treated. That real-world bias is exactly what we will look for inside our own model.</a:t>
+            </a:r>
+          </a:p>
+        </p:txBody>
+      </p:sp>
+      <p:sp>
+        <p:nvSpPr>
+          <p:cNvPr id="4" name="Slide Number Placeholder 3"/>
+          <p:cNvSpPr>
+            <a:spLocks noGrp="1"/>
+          </p:cNvSpPr>
+          <p:nvPr>
+            <p:ph type="sldNum" idx="5" sz="quarter"/>
+          </p:nvPr>
+        </p:nvSpPr>
+        <p:spPr/>
+      </p:sp>
+    </p:spTree>
+  </p:cSld>
+  <p:clrMapOvr>
+    <a:masterClrMapping/>
+  </p:clrMapOvr>
+</p:notes>
+</file>
+
+<file path=ppt/notesSlides/notesSlide4.xml><?xml version="1.0" encoding="utf-8"?>
+<p:notes xmlns:a="http://schemas.openxmlformats.org/drawingml/2006/main" xmlns:p="http://schemas.openxmlformats.org/presentationml/2006/main" xmlns:r="http://schemas.openxmlformats.org/officeDocument/2006/relationships">
+  <p:cSld>
+    <p:spTree>
+      <p:nvGrpSpPr>
+        <p:cNvPr id="1" name=""/>
+        <p:cNvGrpSpPr/>
+        <p:nvPr/>
+      </p:nvGrpSpPr>
+      <p:grpSpPr>
+        <a:xfrm>
+          <a:off x="0" y="0"/>
+          <a:ext cx="0" cy="0"/>
+          <a:chOff x="0" y="0"/>
+          <a:chExt cx="0" cy="0"/>
+        </a:xfrm>
+      </p:grpSpPr>
+      <p:sp>
+        <p:nvSpPr>
+          <p:cNvPr id="2" name="Slide Image Placeholder 1"/>
+          <p:cNvSpPr>
+            <a:spLocks noGrp="1"/>
+          </p:cNvSpPr>
+          <p:nvPr>
+            <p:ph type="sldImg" idx="2"/>
+          </p:nvPr>
+        </p:nvSpPr>
+        <p:spPr/>
+      </p:sp>
+      <p:sp>
+        <p:nvSpPr>
+          <p:cNvPr id="3" name="Notes Placeholder 2"/>
+          <p:cNvSpPr>
+            <a:spLocks noGrp="1"/>
+          </p:cNvSpPr>
+          <p:nvPr>
+            <p:ph type="body" idx="3" sz="quarter"/>
+          </p:nvPr>
+        </p:nvSpPr>
+        <p:spPr/>
+        <p:txBody>
+          <a:bodyPr/>
+          <a:lstStyle/>
+          <a:p>
+            <a:r>
+              <a:rPr b="1" sz="1300">
+                <a:latin typeface="Geist Mono"/>
+              </a:rPr>
+              <a:t>Methods</a:t>
+            </a:r>
+          </a:p>
+          <a:p>
+            <a:r>
+              <a:rPr b="0" sz="1100">
+                <a:latin typeface="Geist"/>
+              </a:rPr>
+              <a:t>Now we turn to what we actually built. This section covers the prediction task, the dataset, and the four models we compared -- and why the choice of algorithm turns out to be the least interesting decision of all.</a:t>
+            </a:r>
+          </a:p>
+        </p:txBody>
+      </p:sp>
+      <p:sp>
+        <p:nvSpPr>
+          <p:cNvPr id="4" name="Slide Number Placeholder 3"/>
+          <p:cNvSpPr>
+            <a:spLocks noGrp="1"/>
+          </p:cNvSpPr>
+          <p:nvPr>
+            <p:ph type="sldNum" idx="5" sz="quarter"/>
+          </p:nvPr>
+        </p:nvSpPr>
+        <p:spPr/>
+      </p:sp>
+    </p:spTree>
+  </p:cSld>
+  <p:clrMapOvr>
+    <a:masterClrMapping/>
+  </p:clrMapOvr>
+</p:notes>
+</file>
+
+<file path=ppt/notesSlides/notesSlide5.xml><?xml version="1.0" encoding="utf-8"?>
+<p:notes xmlns:a="http://schemas.openxmlformats.org/drawingml/2006/main" xmlns:p="http://schemas.openxmlformats.org/presentationml/2006/main" xmlns:r="http://schemas.openxmlformats.org/officeDocument/2006/relationships">
+  <p:cSld>
+    <p:spTree>
+      <p:nvGrpSpPr>
+        <p:cNvPr id="1" name=""/>
+        <p:cNvGrpSpPr/>
+        <p:nvPr/>
+      </p:nvGrpSpPr>
+      <p:grpSpPr>
+        <a:xfrm>
+          <a:off x="0" y="0"/>
+          <a:ext cx="0" cy="0"/>
+          <a:chOff x="0" y="0"/>
+          <a:chExt cx="0" cy="0"/>
+        </a:xfrm>
+      </p:grpSpPr>
+      <p:sp>
+        <p:nvSpPr>
+          <p:cNvPr id="2" name="Slide Image Placeholder 1"/>
+          <p:cNvSpPr>
+            <a:spLocks noGrp="1"/>
+          </p:cNvSpPr>
+          <p:nvPr>
+            <p:ph type="sldImg" idx="2"/>
+          </p:nvPr>
+        </p:nvSpPr>
+        <p:spPr/>
+      </p:sp>
+      <p:sp>
+        <p:nvSpPr>
+          <p:cNvPr id="3" name="Notes Placeholder 2"/>
+          <p:cNvSpPr>
+            <a:spLocks noGrp="1"/>
+          </p:cNvSpPr>
+          <p:nvPr>
+            <p:ph type="body" idx="3" sz="quarter"/>
+          </p:nvPr>
+        </p:nvSpPr>
+        <p:spPr/>
+        <p:txBody>
+          <a:bodyPr/>
+          <a:lstStyle/>
+          <a:p>
+            <a:r>
+              <a:rPr b="1" sz="1300">
+                <a:latin typeface="Geist Mono"/>
+              </a:rPr>
+              <a:t>The task and the data</a:t>
+            </a:r>
+          </a:p>
+          <a:p>
+            <a:r>
+              <a:rPr b="0" sz="1100">
+                <a:latin typeface="Geist"/>
+              </a:rPr>
+              <a:t>Our job is a simple yes/no prediction from a routine checkup, using the classic Cleveland dataset: 303 patients, 13 features, graded on patients the model never saw. Because tabular data like this is easy for any model, the real questions are which features matter and who the model works for, not which algorithm wins.</a:t>
+            </a:r>
+          </a:p>
+        </p:txBody>
+      </p:sp>
+      <p:sp>
+        <p:nvSpPr>
+          <p:cNvPr id="4" name="Slide Number Placeholder 3"/>
+          <p:cNvSpPr>
+            <a:spLocks noGrp="1"/>
+          </p:cNvSpPr>
+          <p:nvPr>
+            <p:ph type="sldNum" idx="5" sz="quarter"/>
+          </p:nvPr>
+        </p:nvSpPr>
+        <p:spPr/>
+      </p:sp>
+    </p:spTree>
+  </p:cSld>
+  <p:clrMapOvr>
+    <a:masterClrMapping/>
+  </p:clrMapOvr>
+</p:notes>
+</file>
+
+<file path=ppt/notesSlides/notesSlide6.xml><?xml version="1.0" encoding="utf-8"?>
+<p:notes xmlns:a="http://schemas.openxmlformats.org/drawingml/2006/main" xmlns:p="http://schemas.openxmlformats.org/presentationml/2006/main" xmlns:r="http://schemas.openxmlformats.org/officeDocument/2006/relationships">
+  <p:cSld>
+    <p:spTree>
+      <p:nvGrpSpPr>
+        <p:cNvPr id="1" name=""/>
+        <p:cNvGrpSpPr/>
+        <p:nvPr/>
+      </p:nvGrpSpPr>
+      <p:grpSpPr>
+        <a:xfrm>
+          <a:off x="0" y="0"/>
+          <a:ext cx="0" cy="0"/>
+          <a:chOff x="0" y="0"/>
+          <a:chExt cx="0" cy="0"/>
+        </a:xfrm>
+      </p:grpSpPr>
+      <p:sp>
+        <p:nvSpPr>
+          <p:cNvPr id="2" name="Slide Image Placeholder 1"/>
+          <p:cNvSpPr>
+            <a:spLocks noGrp="1"/>
+          </p:cNvSpPr>
+          <p:nvPr>
+            <p:ph type="sldImg" idx="2"/>
+          </p:nvPr>
+        </p:nvSpPr>
+        <p:spPr/>
+      </p:sp>
+      <p:sp>
+        <p:nvSpPr>
+          <p:cNvPr id="3" name="Notes Placeholder 2"/>
+          <p:cNvSpPr>
+            <a:spLocks noGrp="1"/>
+          </p:cNvSpPr>
+          <p:nvPr>
+            <p:ph type="body" idx="3" sz="quarter"/>
+          </p:nvPr>
+        </p:nvSpPr>
+        <p:spPr/>
+        <p:txBody>
+          <a:bodyPr/>
+          <a:lstStyle/>
+          <a:p>
+            <a:r>
+              <a:rPr b="1" sz="1300">
+                <a:latin typeface="Geist Mono"/>
+              </a:rPr>
+              <a:t>Four models, one honest test</a:t>
+            </a:r>
+          </a:p>
+          <a:p>
+            <a:r>
+              <a:rPr b="0" sz="1100">
+                <a:latin typeface="Geist"/>
+              </a:rPr>
+              <a:t>We trained four different models -- a simple logistic regression, two tree ensembles, and a tabular foundation model -- and always compared them to the 'just guess the majority' baseline of about 0.54. Anything that cannot beat that baseline is useless. They all beat it, and they all basically tie.</a:t>
+            </a:r>
+          </a:p>
+        </p:txBody>
+      </p:sp>
+      <p:sp>
+        <p:nvSpPr>
+          <p:cNvPr id="4" name="Slide Number Placeholder 3"/>
+          <p:cNvSpPr>
+            <a:spLocks noGrp="1"/>
+          </p:cNvSpPr>
+          <p:nvPr>
+            <p:ph type="sldNum" idx="5" sz="quarter"/>
+          </p:nvPr>
+        </p:nvSpPr>
+        <p:spPr/>
+      </p:sp>
+    </p:spTree>
+  </p:cSld>
+  <p:clrMapOvr>
+    <a:masterClrMapping/>
+  </p:clrMapOvr>
+</p:notes>
+</file>
+
+<file path=ppt/notesSlides/notesSlide7.xml><?xml version="1.0" encoding="utf-8"?>
+<p:notes xmlns:a="http://schemas.openxmlformats.org/drawingml/2006/main" xmlns:p="http://schemas.openxmlformats.org/presentationml/2006/main" xmlns:r="http://schemas.openxmlformats.org/officeDocument/2006/relationships">
+  <p:cSld>
+    <p:spTree>
+      <p:nvGrpSpPr>
+        <p:cNvPr id="1" name=""/>
+        <p:cNvGrpSpPr/>
+        <p:nvPr/>
+      </p:nvGrpSpPr>
+      <p:grpSpPr>
+        <a:xfrm>
+          <a:off x="0" y="0"/>
+          <a:ext cx="0" cy="0"/>
+          <a:chOff x="0" y="0"/>
+          <a:chExt cx="0" cy="0"/>
+        </a:xfrm>
+      </p:grpSpPr>
+      <p:sp>
+        <p:nvSpPr>
+          <p:cNvPr id="2" name="Slide Image Placeholder 1"/>
+          <p:cNvSpPr>
+            <a:spLocks noGrp="1"/>
+          </p:cNvSpPr>
+          <p:nvPr>
+            <p:ph type="sldImg" idx="2"/>
+          </p:nvPr>
+        </p:nvSpPr>
+        <p:spPr/>
+      </p:sp>
+      <p:sp>
+        <p:nvSpPr>
+          <p:cNvPr id="3" name="Notes Placeholder 2"/>
+          <p:cNvSpPr>
+            <a:spLocks noGrp="1"/>
+          </p:cNvSpPr>
+          <p:nvPr>
+            <p:ph type="body" idx="3" sz="quarter"/>
+          </p:nvPr>
+        </p:nvSpPr>
+        <p:spPr/>
+        <p:txBody>
+          <a:bodyPr/>
+          <a:lstStyle/>
+          <a:p>
+            <a:r>
+              <a:rPr b="1" sz="1300">
+                <a:latin typeface="Geist Mono"/>
+              </a:rPr>
+              <a:t>Results</a:t>
+            </a:r>
+          </a:p>
+          <a:p>
+            <a:r>
+              <a:rPr b="0" sz="1100">
+                <a:latin typeface="Geist"/>
+              </a:rPr>
+              <a:t>Here are the three findings. Watch for a pattern: the flashy model comparison teaches the least, while the two 'boring' experiments -- one feature, and a fairness split -- teach the most.</a:t>
+            </a:r>
+          </a:p>
+        </p:txBody>
+      </p:sp>
+      <p:sp>
+        <p:nvSpPr>
+          <p:cNvPr id="4" name="Slide Number Placeholder 3"/>
+          <p:cNvSpPr>
+            <a:spLocks noGrp="1"/>
+          </p:cNvSpPr>
+          <p:nvPr>
+            <p:ph type="sldNum" idx="5" sz="quarter"/>
+          </p:nvPr>
+        </p:nvSpPr>
+        <p:spPr/>
+      </p:sp>
+    </p:spTree>
+  </p:cSld>
+  <p:clrMapOvr>
+    <a:masterClrMapping/>
+  </p:clrMapOvr>
+</p:notes>
+</file>
+
+<file path=ppt/notesSlides/notesSlide8.xml><?xml version="1.0" encoding="utf-8"?>
+<p:notes xmlns:a="http://schemas.openxmlformats.org/drawingml/2006/main" xmlns:p="http://schemas.openxmlformats.org/presentationml/2006/main" xmlns:r="http://schemas.openxmlformats.org/officeDocument/2006/relationships">
+  <p:cSld>
+    <p:spTree>
+      <p:nvGrpSpPr>
+        <p:cNvPr id="1" name=""/>
+        <p:cNvGrpSpPr/>
+        <p:nvPr/>
+      </p:nvGrpSpPr>
+      <p:grpSpPr>
+        <a:xfrm>
+          <a:off x="0" y="0"/>
+          <a:ext cx="0" cy="0"/>
+          <a:chOff x="0" y="0"/>
+          <a:chExt cx="0" cy="0"/>
+        </a:xfrm>
+      </p:grpSpPr>
+      <p:sp>
+        <p:nvSpPr>
+          <p:cNvPr id="2" name="Slide Image Placeholder 1"/>
+          <p:cNvSpPr>
+            <a:spLocks noGrp="1"/>
+          </p:cNvSpPr>
+          <p:nvPr>
+            <p:ph type="sldImg" idx="2"/>
+          </p:nvPr>
+        </p:nvSpPr>
+        <p:spPr/>
+      </p:sp>
+      <p:sp>
+        <p:nvSpPr>
+          <p:cNvPr id="3" name="Notes Placeholder 2"/>
+          <p:cNvSpPr>
+            <a:spLocks noGrp="1"/>
+          </p:cNvSpPr>
+          <p:nvPr>
+            <p:ph type="body" idx="3" sz="quarter"/>
+          </p:nvPr>
+        </p:nvSpPr>
+        <p:spPr/>
+        <p:txBody>
+          <a:bodyPr/>
+          <a:lstStyle/>
+          <a:p>
+            <a:r>
+              <a:rPr b="1" sz="1300">
+                <a:latin typeface="Geist Mono"/>
+              </a:rPr>
+              <a:t>The data sets the ceiling</a:t>
+            </a:r>
+          </a:p>
+          <a:p>
+            <a:r>
+              <a:rPr b="0" sz="1100">
+                <a:latin typeface="Geist"/>
+              </a:rPr>
+              <a:t>All four models land within a whisker of each other, around 0.80. The lesson is that on clean tabular data the algorithm barely matters -- a plain logistic regression matches a fancy foundation model. The ceiling is set by the data itself, not by how clever the model is.</a:t>
+            </a:r>
+          </a:p>
+        </p:txBody>
+      </p:sp>
+      <p:sp>
+        <p:nvSpPr>
+          <p:cNvPr id="4" name="Slide Number Placeholder 3"/>
+          <p:cNvSpPr>
+            <a:spLocks noGrp="1"/>
+          </p:cNvSpPr>
+          <p:nvPr>
+            <p:ph type="sldNum" idx="5" sz="quarter"/>
+          </p:nvPr>
+        </p:nvSpPr>
+        <p:spPr/>
+      </p:sp>
+    </p:spTree>
+  </p:cSld>
+  <p:clrMapOvr>
+    <a:masterClrMapping/>
+  </p:clrMapOvr>
+</p:notes>
+</file>
+
+<file path=ppt/notesSlides/notesSlide9.xml><?xml version="1.0" encoding="utf-8"?>
+<p:notes xmlns:a="http://schemas.openxmlformats.org/drawingml/2006/main" xmlns:p="http://schemas.openxmlformats.org/presentationml/2006/main" xmlns:r="http://schemas.openxmlformats.org/officeDocument/2006/relationships">
+  <p:cSld>
+    <p:spTree>
+      <p:nvGrpSpPr>
+        <p:cNvPr id="1" name=""/>
+        <p:cNvGrpSpPr/>
+        <p:nvPr/>
+      </p:nvGrpSpPr>
+      <p:grpSpPr>
+        <a:xfrm>
+          <a:off x="0" y="0"/>
+          <a:ext cx="0" cy="0"/>
+          <a:chOff x="0" y="0"/>
+          <a:chExt cx="0" cy="0"/>
+        </a:xfrm>
+      </p:grpSpPr>
+      <p:sp>
+        <p:nvSpPr>
+          <p:cNvPr id="2" name="Slide Image Placeholder 1"/>
+          <p:cNvSpPr>
+            <a:spLocks noGrp="1"/>
+          </p:cNvSpPr>
+          <p:nvPr>
+            <p:ph type="sldImg" idx="2"/>
+          </p:nvPr>
+        </p:nvSpPr>
+        <p:spPr/>
+      </p:sp>
+      <p:sp>
+        <p:nvSpPr>
+          <p:cNvPr id="3" name="Notes Placeholder 2"/>
+          <p:cNvSpPr>
+            <a:spLocks noGrp="1"/>
+          </p:cNvSpPr>
+          <p:nvPr>
+            <p:ph type="body" idx="3" sz="quarter"/>
+          </p:nvPr>
+        </p:nvSpPr>
+        <p:spPr/>
+        <p:txBody>
+          <a:bodyPr/>
+          <a:lstStyle/>
+          <a:p>
+            <a:r>
+              <a:rPr b="1" sz="1300">
+                <a:latin typeface="Geist Mono"/>
+              </a:rPr>
+              <a:t>Cholesterol alone is a weak predictor</a:t>
+            </a:r>
+          </a:p>
+          <a:p>
+            <a:r>
+              <a:rPr b="0" sz="1100">
+                <a:latin typeface="Geist"/>
+              </a:rPr>
+              <a:t>We gave one model only the cholesterol column and it scored near a coin flip, while dropping cholesterol entirely barely hurt. Cholesterol matters over decades, but on its own it is a weak clue for who has disease right now -- which is why doctors combine many measurements. This is the 'stack of factors' idea made concrete.</a:t>
+            </a:r>
+          </a:p>
+        </p:txBody>
+      </p:sp>
+      <p:sp>
+        <p:nvSpPr>
+          <p:cNvPr id="4" name="Slide Number Placeholder 3"/>
+          <p:cNvSpPr>
+            <a:spLocks noGrp="1"/>
+          </p:cNvSpPr>
+          <p:nvPr>
+            <p:ph type="sldNum" idx="5" sz="quarter"/>
+          </p:nvPr>
+        </p:nvSpPr>
+        <p:spPr/>
+      </p:sp>
+    </p:spTree>
+  </p:cSld>
+  <p:clrMapOvr>
+    <a:masterClrMapping/>
+  </p:clrMapOvr>
+</p:notes>
 </file>
 
 <file path=ppt/slideLayouts/slideLayout1.xml><?xml version="1.0" encoding="utf-8"?>
@@ -3886,8 +5451,8 @@
         </p:nvSpPr>
         <p:spPr>
           <a:xfrm>
-            <a:off x="7322515" y="1389888"/>
-            <a:ext cx="91440" cy="91440"/>
+            <a:off x="7340803" y="3154680"/>
+            <a:ext cx="100584" cy="100584"/>
           </a:xfrm>
           <a:prstGeom prst="rect">
             <a:avLst/>
@@ -3930,8 +5495,8 @@
         </p:nvSpPr>
         <p:spPr>
           <a:xfrm>
-            <a:off x="7523683" y="1325880"/>
-            <a:ext cx="4016044" cy="2020824"/>
+            <a:off x="7560259" y="1325880"/>
+            <a:ext cx="3942892" cy="4571999"/>
           </a:xfrm>
           <a:prstGeom prst="rect">
             <a:avLst/>
@@ -3939,14 +5504,14 @@
           <a:noFill/>
         </p:spPr>
         <p:txBody>
-          <a:bodyPr wrap="square" anchor="t" lIns="0" rIns="0" tIns="0" bIns="0">
+          <a:bodyPr wrap="square" anchor="ctr" lIns="0" rIns="0" tIns="0" bIns="0">
             <a:spAutoFit/>
           </a:bodyPr>
           <a:lstStyle/>
           <a:p>
             <a:pPr algn="l"/>
             <a:r>
-              <a:rPr sz="1300" b="0" i="0">
+              <a:rPr sz="1500" b="0" i="0">
                 <a:solidFill>
                   <a:srgbClr val="14141C"/>
                 </a:solidFill>
@@ -4297,8 +5862,8 @@
         </p:nvSpPr>
         <p:spPr>
           <a:xfrm>
-            <a:off x="7322515" y="1389888"/>
-            <a:ext cx="91440" cy="91440"/>
+            <a:off x="7340803" y="2532888"/>
+            <a:ext cx="100584" cy="100584"/>
           </a:xfrm>
           <a:prstGeom prst="rect">
             <a:avLst/>
@@ -4341,8 +5906,8 @@
         </p:nvSpPr>
         <p:spPr>
           <a:xfrm>
-            <a:off x="7523683" y="1325880"/>
-            <a:ext cx="4016044" cy="256032"/>
+            <a:off x="7560259" y="2468880"/>
+            <a:ext cx="3942892" cy="548640"/>
           </a:xfrm>
           <a:prstGeom prst="rect">
             <a:avLst/>
@@ -4357,7 +5922,7 @@
           <a:p>
             <a:pPr algn="l"/>
             <a:r>
-              <a:rPr sz="1300" b="0" i="0">
+              <a:rPr sz="1600" b="1" i="0">
                 <a:solidFill>
                   <a:srgbClr val="14141C"/>
                 </a:solidFill>
@@ -4376,8 +5941,8 @@
         </p:nvSpPr>
         <p:spPr>
           <a:xfrm>
-            <a:off x="7322515" y="1773936"/>
-            <a:ext cx="91440" cy="91440"/>
+            <a:off x="7340803" y="3246120"/>
+            <a:ext cx="100584" cy="100584"/>
           </a:xfrm>
           <a:prstGeom prst="rect">
             <a:avLst/>
@@ -4420,8 +5985,8 @@
         </p:nvSpPr>
         <p:spPr>
           <a:xfrm>
-            <a:off x="7523683" y="1709928"/>
-            <a:ext cx="4016044" cy="1627632"/>
+            <a:off x="7560259" y="3182112"/>
+            <a:ext cx="3942892" cy="1920240"/>
           </a:xfrm>
           <a:prstGeom prst="rect">
             <a:avLst/>
@@ -4436,7 +6001,7 @@
           <a:p>
             <a:pPr algn="l"/>
             <a:r>
-              <a:rPr sz="1300" b="0" i="0">
+              <a:rPr sz="1500" b="0" i="0">
                 <a:solidFill>
                   <a:srgbClr val="14141C"/>
                 </a:solidFill>
@@ -5234,8 +6799,8 @@
         </p:nvSpPr>
         <p:spPr>
           <a:xfrm>
-            <a:off x="7322515" y="1389888"/>
-            <a:ext cx="91440" cy="91440"/>
+            <a:off x="7340803" y="2532888"/>
+            <a:ext cx="100584" cy="100584"/>
           </a:xfrm>
           <a:prstGeom prst="rect">
             <a:avLst/>
@@ -5278,8 +6843,8 @@
         </p:nvSpPr>
         <p:spPr>
           <a:xfrm>
-            <a:off x="7523683" y="1325880"/>
-            <a:ext cx="4016044" cy="448056"/>
+            <a:off x="7560259" y="2468880"/>
+            <a:ext cx="3942892" cy="548640"/>
           </a:xfrm>
           <a:prstGeom prst="rect">
             <a:avLst/>
@@ -5294,7 +6859,7 @@
           <a:p>
             <a:pPr algn="l"/>
             <a:r>
-              <a:rPr sz="1300" b="0" i="0">
+              <a:rPr sz="1600" b="1" i="0">
                 <a:solidFill>
                   <a:srgbClr val="14141C"/>
                 </a:solidFill>
@@ -5313,8 +6878,8 @@
         </p:nvSpPr>
         <p:spPr>
           <a:xfrm>
-            <a:off x="7322515" y="1965960"/>
-            <a:ext cx="91440" cy="91440"/>
+            <a:off x="7340803" y="3246120"/>
+            <a:ext cx="100584" cy="100584"/>
           </a:xfrm>
           <a:prstGeom prst="rect">
             <a:avLst/>
@@ -5357,8 +6922,8 @@
         </p:nvSpPr>
         <p:spPr>
           <a:xfrm>
-            <a:off x="7523683" y="1901952"/>
-            <a:ext cx="4016044" cy="1627632"/>
+            <a:off x="7560259" y="3182112"/>
+            <a:ext cx="3942892" cy="1920240"/>
           </a:xfrm>
           <a:prstGeom prst="rect">
             <a:avLst/>
@@ -5373,7 +6938,7 @@
           <a:p>
             <a:pPr algn="l"/>
             <a:r>
-              <a:rPr sz="1300" b="0" i="0">
+              <a:rPr sz="1500" b="0" i="0">
                 <a:solidFill>
                   <a:srgbClr val="14141C"/>
                 </a:solidFill>
@@ -5663,7 +7228,7 @@
             <a:avLst/>
           </a:prstGeom>
           <a:solidFill>
-            <a:srgbClr val="9A3412"/>
+            <a:srgbClr val="40E0D0"/>
           </a:solidFill>
           <a:ln>
             <a:noFill/>
@@ -5700,8 +7265,8 @@
         </p:nvSpPr>
         <p:spPr>
           <a:xfrm>
-            <a:off x="640080" y="1289304"/>
-            <a:ext cx="3169920" cy="640080"/>
+            <a:off x="731520" y="2761488"/>
+            <a:ext cx="2987040" cy="548640"/>
           </a:xfrm>
           <a:prstGeom prst="rect">
             <a:avLst/>
@@ -5716,7 +7281,7 @@
           <a:p>
             <a:pPr algn="l"/>
             <a:r>
-              <a:rPr sz="1500" b="1" i="0">
+              <a:rPr sz="1900" b="1" i="0">
                 <a:solidFill>
                   <a:srgbClr val="14141C"/>
                 </a:solidFill>
@@ -5729,14 +7294,58 @@
       </p:sp>
       <p:sp>
         <p:nvSpPr>
-          <p:cNvPr id="10" name="TextBox 9"/>
+          <p:cNvPr id="10" name="Rectangle 9"/>
+          <p:cNvSpPr/>
+          <p:nvPr/>
+        </p:nvSpPr>
+        <p:spPr>
+          <a:xfrm>
+            <a:off x="749808" y="3346704"/>
+            <a:ext cx="658368" cy="32004"/>
+          </a:xfrm>
+          <a:prstGeom prst="rect">
+            <a:avLst/>
+          </a:prstGeom>
+          <a:solidFill>
+            <a:srgbClr val="40E0D0"/>
+          </a:solidFill>
+          <a:ln>
+            <a:noFill/>
+          </a:ln>
+          <a:effectLst/>
+        </p:spPr>
+        <p:style>
+          <a:lnRef idx="1">
+            <a:schemeClr val="accent1"/>
+          </a:lnRef>
+          <a:fillRef idx="3">
+            <a:schemeClr val="accent1"/>
+          </a:fillRef>
+          <a:effectRef idx="2">
+            <a:schemeClr val="accent1"/>
+          </a:effectRef>
+          <a:fontRef idx="minor">
+            <a:schemeClr val="lt1"/>
+          </a:fontRef>
+        </p:style>
+        <p:txBody>
+          <a:bodyPr rtlCol="0" anchor="ctr"/>
+          <a:lstStyle/>
+          <a:p>
+            <a:pPr algn="ctr"/>
+          </a:p>
+        </p:txBody>
+      </p:sp>
+      <p:sp>
+        <p:nvSpPr>
+          <p:cNvPr id="11" name="TextBox 10"/>
           <p:cNvSpPr txBox="1"/>
           <p:nvPr/>
         </p:nvSpPr>
         <p:spPr>
           <a:xfrm>
-            <a:off x="640080" y="2011680"/>
-            <a:ext cx="3169920" cy="4069079"/>
+            <a:off x="731520" y="3547872"/>
+            <a:ext cx="2987040" cy="2606039"/>
           </a:xfrm>
           <a:prstGeom prst="rect">
             <a:avLst/>
@@ -5751,7 +7360,7 @@
           <a:p>
             <a:pPr algn="l"/>
             <a:r>
-              <a:rPr sz="1200" b="0" i="0">
+              <a:rPr sz="1500" b="0" i="0">
                 <a:solidFill>
                   <a:srgbClr val="555560"/>
                 </a:solidFill>
@@ -5764,7 +7373,7 @@
       </p:sp>
       <p:sp>
         <p:nvSpPr>
-          <p:cNvPr id="11" name="Rectangle 10"/>
+          <p:cNvPr id="12" name="Rectangle 11"/>
           <p:cNvSpPr/>
           <p:nvPr/>
         </p:nvSpPr>
@@ -5808,7 +7417,7 @@
       </p:sp>
       <p:sp>
         <p:nvSpPr>
-          <p:cNvPr id="12" name="Rectangle 11"/>
+          <p:cNvPr id="13" name="Rectangle 12"/>
           <p:cNvSpPr/>
           <p:nvPr/>
         </p:nvSpPr>
@@ -5821,7 +7430,7 @@
             <a:avLst/>
           </a:prstGeom>
           <a:solidFill>
-            <a:srgbClr val="1E3A8A"/>
+            <a:srgbClr val="FF1493"/>
           </a:solidFill>
           <a:ln>
             <a:noFill/>
@@ -5852,14 +7461,14 @@
       </p:sp>
       <p:sp>
         <p:nvSpPr>
-          <p:cNvPr id="13" name="TextBox 12"/>
+          <p:cNvPr id="14" name="TextBox 13"/>
           <p:cNvSpPr txBox="1"/>
           <p:nvPr/>
         </p:nvSpPr>
         <p:spPr>
           <a:xfrm>
-            <a:off x="4495800" y="1289304"/>
-            <a:ext cx="3169920" cy="640080"/>
+            <a:off x="4587240" y="2761488"/>
+            <a:ext cx="2987040" cy="548640"/>
           </a:xfrm>
           <a:prstGeom prst="rect">
             <a:avLst/>
@@ -5874,7 +7483,7 @@
           <a:p>
             <a:pPr algn="l"/>
             <a:r>
-              <a:rPr sz="1500" b="1" i="0">
+              <a:rPr sz="1900" b="1" i="0">
                 <a:solidFill>
                   <a:srgbClr val="14141C"/>
                 </a:solidFill>
@@ -5887,14 +7496,58 @@
       </p:sp>
       <p:sp>
         <p:nvSpPr>
-          <p:cNvPr id="14" name="TextBox 13"/>
+          <p:cNvPr id="15" name="Rectangle 14"/>
+          <p:cNvSpPr/>
+          <p:nvPr/>
+        </p:nvSpPr>
+        <p:spPr>
+          <a:xfrm>
+            <a:off x="4605528" y="3346704"/>
+            <a:ext cx="658368" cy="32004"/>
+          </a:xfrm>
+          <a:prstGeom prst="rect">
+            <a:avLst/>
+          </a:prstGeom>
+          <a:solidFill>
+            <a:srgbClr val="FF1493"/>
+          </a:solidFill>
+          <a:ln>
+            <a:noFill/>
+          </a:ln>
+          <a:effectLst/>
+        </p:spPr>
+        <p:style>
+          <a:lnRef idx="1">
+            <a:schemeClr val="accent1"/>
+          </a:lnRef>
+          <a:fillRef idx="3">
+            <a:schemeClr val="accent1"/>
+          </a:fillRef>
+          <a:effectRef idx="2">
+            <a:schemeClr val="accent1"/>
+          </a:effectRef>
+          <a:fontRef idx="minor">
+            <a:schemeClr val="lt1"/>
+          </a:fontRef>
+        </p:style>
+        <p:txBody>
+          <a:bodyPr rtlCol="0" anchor="ctr"/>
+          <a:lstStyle/>
+          <a:p>
+            <a:pPr algn="ctr"/>
+          </a:p>
+        </p:txBody>
+      </p:sp>
+      <p:sp>
+        <p:nvSpPr>
+          <p:cNvPr id="16" name="TextBox 15"/>
           <p:cNvSpPr txBox="1"/>
           <p:nvPr/>
         </p:nvSpPr>
         <p:spPr>
           <a:xfrm>
-            <a:off x="4495800" y="2011680"/>
-            <a:ext cx="3169920" cy="4069079"/>
+            <a:off x="4587240" y="3547872"/>
+            <a:ext cx="2987040" cy="2606039"/>
           </a:xfrm>
           <a:prstGeom prst="rect">
             <a:avLst/>
@@ -5909,7 +7562,7 @@
           <a:p>
             <a:pPr algn="l"/>
             <a:r>
-              <a:rPr sz="1200" b="0" i="0">
+              <a:rPr sz="1500" b="0" i="0">
                 <a:solidFill>
                   <a:srgbClr val="555560"/>
                 </a:solidFill>
@@ -5922,7 +7575,7 @@
       </p:sp>
       <p:sp>
         <p:nvSpPr>
-          <p:cNvPr id="15" name="Rectangle 14"/>
+          <p:cNvPr id="17" name="Rectangle 16"/>
           <p:cNvSpPr/>
           <p:nvPr/>
         </p:nvSpPr>
@@ -5966,7 +7619,7 @@
       </p:sp>
       <p:sp>
         <p:nvSpPr>
-          <p:cNvPr id="16" name="Rectangle 15"/>
+          <p:cNvPr id="18" name="Rectangle 17"/>
           <p:cNvSpPr/>
           <p:nvPr/>
         </p:nvSpPr>
@@ -5979,7 +7632,7 @@
             <a:avLst/>
           </a:prstGeom>
           <a:solidFill>
-            <a:srgbClr val="115E59"/>
+            <a:srgbClr val="F0C840"/>
           </a:solidFill>
           <a:ln>
             <a:noFill/>
@@ -6010,14 +7663,14 @@
       </p:sp>
       <p:sp>
         <p:nvSpPr>
-          <p:cNvPr id="17" name="TextBox 16"/>
+          <p:cNvPr id="19" name="TextBox 18"/>
           <p:cNvSpPr txBox="1"/>
           <p:nvPr/>
         </p:nvSpPr>
         <p:spPr>
           <a:xfrm>
-            <a:off x="8351520" y="1289304"/>
-            <a:ext cx="3169920" cy="640080"/>
+            <a:off x="8442960" y="2761488"/>
+            <a:ext cx="2987040" cy="548640"/>
           </a:xfrm>
           <a:prstGeom prst="rect">
             <a:avLst/>
@@ -6032,7 +7685,7 @@
           <a:p>
             <a:pPr algn="l"/>
             <a:r>
-              <a:rPr sz="1500" b="1" i="0">
+              <a:rPr sz="1900" b="1" i="0">
                 <a:solidFill>
                   <a:srgbClr val="14141C"/>
                 </a:solidFill>
@@ -6045,14 +7698,58 @@
       </p:sp>
       <p:sp>
         <p:nvSpPr>
-          <p:cNvPr id="18" name="TextBox 17"/>
+          <p:cNvPr id="20" name="Rectangle 19"/>
+          <p:cNvSpPr/>
+          <p:nvPr/>
+        </p:nvSpPr>
+        <p:spPr>
+          <a:xfrm>
+            <a:off x="8461248" y="3346704"/>
+            <a:ext cx="658368" cy="32004"/>
+          </a:xfrm>
+          <a:prstGeom prst="rect">
+            <a:avLst/>
+          </a:prstGeom>
+          <a:solidFill>
+            <a:srgbClr val="F0C840"/>
+          </a:solidFill>
+          <a:ln>
+            <a:noFill/>
+          </a:ln>
+          <a:effectLst/>
+        </p:spPr>
+        <p:style>
+          <a:lnRef idx="1">
+            <a:schemeClr val="accent1"/>
+          </a:lnRef>
+          <a:fillRef idx="3">
+            <a:schemeClr val="accent1"/>
+          </a:fillRef>
+          <a:effectRef idx="2">
+            <a:schemeClr val="accent1"/>
+          </a:effectRef>
+          <a:fontRef idx="minor">
+            <a:schemeClr val="lt1"/>
+          </a:fontRef>
+        </p:style>
+        <p:txBody>
+          <a:bodyPr rtlCol="0" anchor="ctr"/>
+          <a:lstStyle/>
+          <a:p>
+            <a:pPr algn="ctr"/>
+          </a:p>
+        </p:txBody>
+      </p:sp>
+      <p:sp>
+        <p:nvSpPr>
+          <p:cNvPr id="21" name="TextBox 20"/>
           <p:cNvSpPr txBox="1"/>
           <p:nvPr/>
         </p:nvSpPr>
         <p:spPr>
           <a:xfrm>
-            <a:off x="8351520" y="2011680"/>
-            <a:ext cx="3169920" cy="4069079"/>
+            <a:off x="8442960" y="3547872"/>
+            <a:ext cx="2987040" cy="2606039"/>
           </a:xfrm>
           <a:prstGeom prst="rect">
             <a:avLst/>
@@ -6067,7 +7764,7 @@
           <a:p>
             <a:pPr algn="l"/>
             <a:r>
-              <a:rPr sz="1200" b="0" i="0">
+              <a:rPr sz="1500" b="0" i="0">
                 <a:solidFill>
                   <a:srgbClr val="555560"/>
                 </a:solidFill>
@@ -6804,7 +8501,7 @@
             <a:avLst/>
           </a:prstGeom>
           <a:solidFill>
-            <a:srgbClr val="9A3412"/>
+            <a:srgbClr val="40E0D0"/>
           </a:solidFill>
           <a:ln>
             <a:noFill/>
@@ -6841,8 +8538,8 @@
         </p:nvSpPr>
         <p:spPr>
           <a:xfrm>
-            <a:off x="640080" y="1289304"/>
-            <a:ext cx="3169920" cy="640080"/>
+            <a:off x="731520" y="2761488"/>
+            <a:ext cx="2987040" cy="548640"/>
           </a:xfrm>
           <a:prstGeom prst="rect">
             <a:avLst/>
@@ -6857,7 +8554,7 @@
           <a:p>
             <a:pPr algn="l"/>
             <a:r>
-              <a:rPr sz="1500" b="1" i="0">
+              <a:rPr sz="1900" b="1" i="0">
                 <a:solidFill>
                   <a:srgbClr val="14141C"/>
                 </a:solidFill>
@@ -6870,14 +8567,58 @@
       </p:sp>
       <p:sp>
         <p:nvSpPr>
-          <p:cNvPr id="10" name="TextBox 9"/>
+          <p:cNvPr id="10" name="Rectangle 9"/>
+          <p:cNvSpPr/>
+          <p:nvPr/>
+        </p:nvSpPr>
+        <p:spPr>
+          <a:xfrm>
+            <a:off x="749808" y="3346704"/>
+            <a:ext cx="658368" cy="32004"/>
+          </a:xfrm>
+          <a:prstGeom prst="rect">
+            <a:avLst/>
+          </a:prstGeom>
+          <a:solidFill>
+            <a:srgbClr val="40E0D0"/>
+          </a:solidFill>
+          <a:ln>
+            <a:noFill/>
+          </a:ln>
+          <a:effectLst/>
+        </p:spPr>
+        <p:style>
+          <a:lnRef idx="1">
+            <a:schemeClr val="accent1"/>
+          </a:lnRef>
+          <a:fillRef idx="3">
+            <a:schemeClr val="accent1"/>
+          </a:fillRef>
+          <a:effectRef idx="2">
+            <a:schemeClr val="accent1"/>
+          </a:effectRef>
+          <a:fontRef idx="minor">
+            <a:schemeClr val="lt1"/>
+          </a:fontRef>
+        </p:style>
+        <p:txBody>
+          <a:bodyPr rtlCol="0" anchor="ctr"/>
+          <a:lstStyle/>
+          <a:p>
+            <a:pPr algn="ctr"/>
+          </a:p>
+        </p:txBody>
+      </p:sp>
+      <p:sp>
+        <p:nvSpPr>
+          <p:cNvPr id="11" name="TextBox 10"/>
           <p:cNvSpPr txBox="1"/>
           <p:nvPr/>
         </p:nvSpPr>
         <p:spPr>
           <a:xfrm>
-            <a:off x="640080" y="2011680"/>
-            <a:ext cx="3169920" cy="4069079"/>
+            <a:off x="731520" y="3547872"/>
+            <a:ext cx="2987040" cy="2606039"/>
           </a:xfrm>
           <a:prstGeom prst="rect">
             <a:avLst/>
@@ -6892,7 +8633,7 @@
           <a:p>
             <a:pPr algn="l"/>
             <a:r>
-              <a:rPr sz="1200" b="0" i="0">
+              <a:rPr sz="1500" b="0" i="0">
                 <a:solidFill>
                   <a:srgbClr val="555560"/>
                 </a:solidFill>
@@ -6905,7 +8646,7 @@
       </p:sp>
       <p:sp>
         <p:nvSpPr>
-          <p:cNvPr id="11" name="Rectangle 10"/>
+          <p:cNvPr id="12" name="Rectangle 11"/>
           <p:cNvSpPr/>
           <p:nvPr/>
         </p:nvSpPr>
@@ -6949,7 +8690,7 @@
       </p:sp>
       <p:sp>
         <p:nvSpPr>
-          <p:cNvPr id="12" name="Rectangle 11"/>
+          <p:cNvPr id="13" name="Rectangle 12"/>
           <p:cNvSpPr/>
           <p:nvPr/>
         </p:nvSpPr>
@@ -6962,7 +8703,7 @@
             <a:avLst/>
           </a:prstGeom>
           <a:solidFill>
-            <a:srgbClr val="1E3A8A"/>
+            <a:srgbClr val="FF1493"/>
           </a:solidFill>
           <a:ln>
             <a:noFill/>
@@ -6993,14 +8734,14 @@
       </p:sp>
       <p:sp>
         <p:nvSpPr>
-          <p:cNvPr id="13" name="TextBox 12"/>
+          <p:cNvPr id="14" name="TextBox 13"/>
           <p:cNvSpPr txBox="1"/>
           <p:nvPr/>
         </p:nvSpPr>
         <p:spPr>
           <a:xfrm>
-            <a:off x="4495800" y="1289304"/>
-            <a:ext cx="3169920" cy="640080"/>
+            <a:off x="4587240" y="2761488"/>
+            <a:ext cx="2987040" cy="548640"/>
           </a:xfrm>
           <a:prstGeom prst="rect">
             <a:avLst/>
@@ -7015,7 +8756,7 @@
           <a:p>
             <a:pPr algn="l"/>
             <a:r>
-              <a:rPr sz="1500" b="1" i="0">
+              <a:rPr sz="1900" b="1" i="0">
                 <a:solidFill>
                   <a:srgbClr val="14141C"/>
                 </a:solidFill>
@@ -7028,14 +8769,58 @@
       </p:sp>
       <p:sp>
         <p:nvSpPr>
-          <p:cNvPr id="14" name="TextBox 13"/>
+          <p:cNvPr id="15" name="Rectangle 14"/>
+          <p:cNvSpPr/>
+          <p:nvPr/>
+        </p:nvSpPr>
+        <p:spPr>
+          <a:xfrm>
+            <a:off x="4605528" y="3346704"/>
+            <a:ext cx="658368" cy="32004"/>
+          </a:xfrm>
+          <a:prstGeom prst="rect">
+            <a:avLst/>
+          </a:prstGeom>
+          <a:solidFill>
+            <a:srgbClr val="FF1493"/>
+          </a:solidFill>
+          <a:ln>
+            <a:noFill/>
+          </a:ln>
+          <a:effectLst/>
+        </p:spPr>
+        <p:style>
+          <a:lnRef idx="1">
+            <a:schemeClr val="accent1"/>
+          </a:lnRef>
+          <a:fillRef idx="3">
+            <a:schemeClr val="accent1"/>
+          </a:fillRef>
+          <a:effectRef idx="2">
+            <a:schemeClr val="accent1"/>
+          </a:effectRef>
+          <a:fontRef idx="minor">
+            <a:schemeClr val="lt1"/>
+          </a:fontRef>
+        </p:style>
+        <p:txBody>
+          <a:bodyPr rtlCol="0" anchor="ctr"/>
+          <a:lstStyle/>
+          <a:p>
+            <a:pPr algn="ctr"/>
+          </a:p>
+        </p:txBody>
+      </p:sp>
+      <p:sp>
+        <p:nvSpPr>
+          <p:cNvPr id="16" name="TextBox 15"/>
           <p:cNvSpPr txBox="1"/>
           <p:nvPr/>
         </p:nvSpPr>
         <p:spPr>
           <a:xfrm>
-            <a:off x="4495800" y="2011680"/>
-            <a:ext cx="3169920" cy="4069079"/>
+            <a:off x="4587240" y="3547872"/>
+            <a:ext cx="2987040" cy="2606039"/>
           </a:xfrm>
           <a:prstGeom prst="rect">
             <a:avLst/>
@@ -7050,7 +8835,7 @@
           <a:p>
             <a:pPr algn="l"/>
             <a:r>
-              <a:rPr sz="1200" b="0" i="0">
+              <a:rPr sz="1500" b="0" i="0">
                 <a:solidFill>
                   <a:srgbClr val="555560"/>
                 </a:solidFill>
@@ -7063,7 +8848,7 @@
       </p:sp>
       <p:sp>
         <p:nvSpPr>
-          <p:cNvPr id="15" name="Rectangle 14"/>
+          <p:cNvPr id="17" name="Rectangle 16"/>
           <p:cNvSpPr/>
           <p:nvPr/>
         </p:nvSpPr>
@@ -7107,7 +8892,7 @@
       </p:sp>
       <p:sp>
         <p:nvSpPr>
-          <p:cNvPr id="16" name="Rectangle 15"/>
+          <p:cNvPr id="18" name="Rectangle 17"/>
           <p:cNvSpPr/>
           <p:nvPr/>
         </p:nvSpPr>
@@ -7120,7 +8905,7 @@
             <a:avLst/>
           </a:prstGeom>
           <a:solidFill>
-            <a:srgbClr val="115E59"/>
+            <a:srgbClr val="F0C840"/>
           </a:solidFill>
           <a:ln>
             <a:noFill/>
@@ -7151,14 +8936,14 @@
       </p:sp>
       <p:sp>
         <p:nvSpPr>
-          <p:cNvPr id="17" name="TextBox 16"/>
+          <p:cNvPr id="19" name="TextBox 18"/>
           <p:cNvSpPr txBox="1"/>
           <p:nvPr/>
         </p:nvSpPr>
         <p:spPr>
           <a:xfrm>
-            <a:off x="8351520" y="1289304"/>
-            <a:ext cx="3169920" cy="640080"/>
+            <a:off x="8442960" y="2761488"/>
+            <a:ext cx="2987040" cy="548640"/>
           </a:xfrm>
           <a:prstGeom prst="rect">
             <a:avLst/>
@@ -7173,7 +8958,7 @@
           <a:p>
             <a:pPr algn="l"/>
             <a:r>
-              <a:rPr sz="1500" b="1" i="0">
+              <a:rPr sz="1900" b="1" i="0">
                 <a:solidFill>
                   <a:srgbClr val="14141C"/>
                 </a:solidFill>
@@ -7186,14 +8971,58 @@
       </p:sp>
       <p:sp>
         <p:nvSpPr>
-          <p:cNvPr id="18" name="TextBox 17"/>
+          <p:cNvPr id="20" name="Rectangle 19"/>
+          <p:cNvSpPr/>
+          <p:nvPr/>
+        </p:nvSpPr>
+        <p:spPr>
+          <a:xfrm>
+            <a:off x="8461248" y="3346704"/>
+            <a:ext cx="658368" cy="32004"/>
+          </a:xfrm>
+          <a:prstGeom prst="rect">
+            <a:avLst/>
+          </a:prstGeom>
+          <a:solidFill>
+            <a:srgbClr val="F0C840"/>
+          </a:solidFill>
+          <a:ln>
+            <a:noFill/>
+          </a:ln>
+          <a:effectLst/>
+        </p:spPr>
+        <p:style>
+          <a:lnRef idx="1">
+            <a:schemeClr val="accent1"/>
+          </a:lnRef>
+          <a:fillRef idx="3">
+            <a:schemeClr val="accent1"/>
+          </a:fillRef>
+          <a:effectRef idx="2">
+            <a:schemeClr val="accent1"/>
+          </a:effectRef>
+          <a:fontRef idx="minor">
+            <a:schemeClr val="lt1"/>
+          </a:fontRef>
+        </p:style>
+        <p:txBody>
+          <a:bodyPr rtlCol="0" anchor="ctr"/>
+          <a:lstStyle/>
+          <a:p>
+            <a:pPr algn="ctr"/>
+          </a:p>
+        </p:txBody>
+      </p:sp>
+      <p:sp>
+        <p:nvSpPr>
+          <p:cNvPr id="21" name="TextBox 20"/>
           <p:cNvSpPr txBox="1"/>
           <p:nvPr/>
         </p:nvSpPr>
         <p:spPr>
           <a:xfrm>
-            <a:off x="8351520" y="2011680"/>
-            <a:ext cx="3169920" cy="4069079"/>
+            <a:off x="8442960" y="3547872"/>
+            <a:ext cx="2987040" cy="2606039"/>
           </a:xfrm>
           <a:prstGeom prst="rect">
             <a:avLst/>
@@ -7208,7 +9037,7 @@
           <a:p>
             <a:pPr algn="l"/>
             <a:r>
-              <a:rPr sz="1200" b="0" i="0">
+              <a:rPr sz="1500" b="0" i="0">
                 <a:solidFill>
                   <a:srgbClr val="555560"/>
                 </a:solidFill>
@@ -8387,8 +10216,8 @@
         </p:nvSpPr>
         <p:spPr>
           <a:xfrm>
-            <a:off x="7322515" y="1389888"/>
-            <a:ext cx="91440" cy="91440"/>
+            <a:off x="7340803" y="2532888"/>
+            <a:ext cx="100584" cy="100584"/>
           </a:xfrm>
           <a:prstGeom prst="rect">
             <a:avLst/>
@@ -8431,8 +10260,8 @@
         </p:nvSpPr>
         <p:spPr>
           <a:xfrm>
-            <a:off x="7523683" y="1325880"/>
-            <a:ext cx="4016044" cy="448056"/>
+            <a:off x="7560259" y="2468880"/>
+            <a:ext cx="3942892" cy="548640"/>
           </a:xfrm>
           <a:prstGeom prst="rect">
             <a:avLst/>
@@ -8447,7 +10276,7 @@
           <a:p>
             <a:pPr algn="l"/>
             <a:r>
-              <a:rPr sz="1300" b="0" i="0">
+              <a:rPr sz="1600" b="1" i="0">
                 <a:solidFill>
                   <a:srgbClr val="14141C"/>
                 </a:solidFill>
@@ -8466,8 +10295,8 @@
         </p:nvSpPr>
         <p:spPr>
           <a:xfrm>
-            <a:off x="7322515" y="1965960"/>
-            <a:ext cx="91440" cy="91440"/>
+            <a:off x="7340803" y="3246120"/>
+            <a:ext cx="100584" cy="100584"/>
           </a:xfrm>
           <a:prstGeom prst="rect">
             <a:avLst/>
@@ -8510,8 +10339,8 @@
         </p:nvSpPr>
         <p:spPr>
           <a:xfrm>
-            <a:off x="7523683" y="1901952"/>
-            <a:ext cx="4016044" cy="1426464"/>
+            <a:off x="7560259" y="3182112"/>
+            <a:ext cx="3942892" cy="1920240"/>
           </a:xfrm>
           <a:prstGeom prst="rect">
             <a:avLst/>
@@ -8526,7 +10355,7 @@
           <a:p>
             <a:pPr algn="l"/>
             <a:r>
-              <a:rPr sz="1300" b="0" i="0">
+              <a:rPr sz="1500" b="0" i="0">
                 <a:solidFill>
                   <a:srgbClr val="14141C"/>
                 </a:solidFill>
@@ -8877,8 +10706,8 @@
         </p:nvSpPr>
         <p:spPr>
           <a:xfrm>
-            <a:off x="7322515" y="1389888"/>
-            <a:ext cx="91440" cy="91440"/>
+            <a:off x="7340803" y="2532888"/>
+            <a:ext cx="100584" cy="100584"/>
           </a:xfrm>
           <a:prstGeom prst="rect">
             <a:avLst/>
@@ -8921,8 +10750,8 @@
         </p:nvSpPr>
         <p:spPr>
           <a:xfrm>
-            <a:off x="7523683" y="1325880"/>
-            <a:ext cx="4016044" cy="448056"/>
+            <a:off x="7560259" y="2468880"/>
+            <a:ext cx="3942892" cy="548640"/>
           </a:xfrm>
           <a:prstGeom prst="rect">
             <a:avLst/>
@@ -8937,7 +10766,7 @@
           <a:p>
             <a:pPr algn="l"/>
             <a:r>
-              <a:rPr sz="1300" b="0" i="0">
+              <a:rPr sz="1600" b="1" i="0">
                 <a:solidFill>
                   <a:srgbClr val="14141C"/>
                 </a:solidFill>
@@ -8956,8 +10785,8 @@
         </p:nvSpPr>
         <p:spPr>
           <a:xfrm>
-            <a:off x="7322515" y="1965960"/>
-            <a:ext cx="91440" cy="91440"/>
+            <a:off x="7340803" y="3246120"/>
+            <a:ext cx="100584" cy="100584"/>
           </a:xfrm>
           <a:prstGeom prst="rect">
             <a:avLst/>
@@ -9000,8 +10829,8 @@
         </p:nvSpPr>
         <p:spPr>
           <a:xfrm>
-            <a:off x="7523683" y="1901952"/>
-            <a:ext cx="4016044" cy="1627632"/>
+            <a:off x="7560259" y="3182112"/>
+            <a:ext cx="3942892" cy="1920240"/>
           </a:xfrm>
           <a:prstGeom prst="rect">
             <a:avLst/>
@@ -9016,7 +10845,7 @@
           <a:p>
             <a:pPr algn="l"/>
             <a:r>
-              <a:rPr sz="1300" b="0" i="0">
+              <a:rPr sz="1500" b="0" i="0">
                 <a:solidFill>
                   <a:srgbClr val="14141C"/>
                 </a:solidFill>
@@ -9753,7 +11582,7 @@
             <a:avLst/>
           </a:prstGeom>
           <a:solidFill>
-            <a:srgbClr val="9A3412"/>
+            <a:srgbClr val="40E0D0"/>
           </a:solidFill>
           <a:ln>
             <a:noFill/>
@@ -9790,8 +11619,8 @@
         </p:nvSpPr>
         <p:spPr>
           <a:xfrm>
-            <a:off x="640080" y="1289304"/>
-            <a:ext cx="3169920" cy="640080"/>
+            <a:off x="731520" y="2761488"/>
+            <a:ext cx="2987040" cy="548640"/>
           </a:xfrm>
           <a:prstGeom prst="rect">
             <a:avLst/>
@@ -9806,7 +11635,7 @@
           <a:p>
             <a:pPr algn="l"/>
             <a:r>
-              <a:rPr sz="1500" b="1" i="0">
+              <a:rPr sz="1900" b="1" i="0">
                 <a:solidFill>
                   <a:srgbClr val="14141C"/>
                 </a:solidFill>
@@ -9819,14 +11648,58 @@
       </p:sp>
       <p:sp>
         <p:nvSpPr>
-          <p:cNvPr id="10" name="TextBox 9"/>
+          <p:cNvPr id="10" name="Rectangle 9"/>
+          <p:cNvSpPr/>
+          <p:nvPr/>
+        </p:nvSpPr>
+        <p:spPr>
+          <a:xfrm>
+            <a:off x="749808" y="3346704"/>
+            <a:ext cx="658368" cy="32004"/>
+          </a:xfrm>
+          <a:prstGeom prst="rect">
+            <a:avLst/>
+          </a:prstGeom>
+          <a:solidFill>
+            <a:srgbClr val="40E0D0"/>
+          </a:solidFill>
+          <a:ln>
+            <a:noFill/>
+          </a:ln>
+          <a:effectLst/>
+        </p:spPr>
+        <p:style>
+          <a:lnRef idx="1">
+            <a:schemeClr val="accent1"/>
+          </a:lnRef>
+          <a:fillRef idx="3">
+            <a:schemeClr val="accent1"/>
+          </a:fillRef>
+          <a:effectRef idx="2">
+            <a:schemeClr val="accent1"/>
+          </a:effectRef>
+          <a:fontRef idx="minor">
+            <a:schemeClr val="lt1"/>
+          </a:fontRef>
+        </p:style>
+        <p:txBody>
+          <a:bodyPr rtlCol="0" anchor="ctr"/>
+          <a:lstStyle/>
+          <a:p>
+            <a:pPr algn="ctr"/>
+          </a:p>
+        </p:txBody>
+      </p:sp>
+      <p:sp>
+        <p:nvSpPr>
+          <p:cNvPr id="11" name="TextBox 10"/>
           <p:cNvSpPr txBox="1"/>
           <p:nvPr/>
         </p:nvSpPr>
         <p:spPr>
           <a:xfrm>
-            <a:off x="640080" y="2011680"/>
-            <a:ext cx="3169920" cy="4069079"/>
+            <a:off x="731520" y="3547872"/>
+            <a:ext cx="2987040" cy="2606039"/>
           </a:xfrm>
           <a:prstGeom prst="rect">
             <a:avLst/>
@@ -9841,7 +11714,7 @@
           <a:p>
             <a:pPr algn="l"/>
             <a:r>
-              <a:rPr sz="1200" b="0" i="0">
+              <a:rPr sz="1500" b="0" i="0">
                 <a:solidFill>
                   <a:srgbClr val="555560"/>
                 </a:solidFill>
@@ -9854,7 +11727,7 @@
       </p:sp>
       <p:sp>
         <p:nvSpPr>
-          <p:cNvPr id="11" name="Rectangle 10"/>
+          <p:cNvPr id="12" name="Rectangle 11"/>
           <p:cNvSpPr/>
           <p:nvPr/>
         </p:nvSpPr>
@@ -9898,7 +11771,7 @@
       </p:sp>
       <p:sp>
         <p:nvSpPr>
-          <p:cNvPr id="12" name="Rectangle 11"/>
+          <p:cNvPr id="13" name="Rectangle 12"/>
           <p:cNvSpPr/>
           <p:nvPr/>
         </p:nvSpPr>
@@ -9911,7 +11784,7 @@
             <a:avLst/>
           </a:prstGeom>
           <a:solidFill>
-            <a:srgbClr val="1E3A8A"/>
+            <a:srgbClr val="FF1493"/>
           </a:solidFill>
           <a:ln>
             <a:noFill/>
@@ -9942,14 +11815,14 @@
       </p:sp>
       <p:sp>
         <p:nvSpPr>
-          <p:cNvPr id="13" name="TextBox 12"/>
+          <p:cNvPr id="14" name="TextBox 13"/>
           <p:cNvSpPr txBox="1"/>
           <p:nvPr/>
         </p:nvSpPr>
         <p:spPr>
           <a:xfrm>
-            <a:off x="4495800" y="1289304"/>
-            <a:ext cx="3169920" cy="640080"/>
+            <a:off x="4587240" y="2761488"/>
+            <a:ext cx="2987040" cy="548640"/>
           </a:xfrm>
           <a:prstGeom prst="rect">
             <a:avLst/>
@@ -9964,7 +11837,7 @@
           <a:p>
             <a:pPr algn="l"/>
             <a:r>
-              <a:rPr sz="1500" b="1" i="0">
+              <a:rPr sz="1900" b="1" i="0">
                 <a:solidFill>
                   <a:srgbClr val="14141C"/>
                 </a:solidFill>
@@ -9977,14 +11850,58 @@
       </p:sp>
       <p:sp>
         <p:nvSpPr>
-          <p:cNvPr id="14" name="TextBox 13"/>
+          <p:cNvPr id="15" name="Rectangle 14"/>
+          <p:cNvSpPr/>
+          <p:nvPr/>
+        </p:nvSpPr>
+        <p:spPr>
+          <a:xfrm>
+            <a:off x="4605528" y="3346704"/>
+            <a:ext cx="658368" cy="32004"/>
+          </a:xfrm>
+          <a:prstGeom prst="rect">
+            <a:avLst/>
+          </a:prstGeom>
+          <a:solidFill>
+            <a:srgbClr val="FF1493"/>
+          </a:solidFill>
+          <a:ln>
+            <a:noFill/>
+          </a:ln>
+          <a:effectLst/>
+        </p:spPr>
+        <p:style>
+          <a:lnRef idx="1">
+            <a:schemeClr val="accent1"/>
+          </a:lnRef>
+          <a:fillRef idx="3">
+            <a:schemeClr val="accent1"/>
+          </a:fillRef>
+          <a:effectRef idx="2">
+            <a:schemeClr val="accent1"/>
+          </a:effectRef>
+          <a:fontRef idx="minor">
+            <a:schemeClr val="lt1"/>
+          </a:fontRef>
+        </p:style>
+        <p:txBody>
+          <a:bodyPr rtlCol="0" anchor="ctr"/>
+          <a:lstStyle/>
+          <a:p>
+            <a:pPr algn="ctr"/>
+          </a:p>
+        </p:txBody>
+      </p:sp>
+      <p:sp>
+        <p:nvSpPr>
+          <p:cNvPr id="16" name="TextBox 15"/>
           <p:cNvSpPr txBox="1"/>
           <p:nvPr/>
         </p:nvSpPr>
         <p:spPr>
           <a:xfrm>
-            <a:off x="4495800" y="2011680"/>
-            <a:ext cx="3169920" cy="4069079"/>
+            <a:off x="4587240" y="3547872"/>
+            <a:ext cx="2987040" cy="2606039"/>
           </a:xfrm>
           <a:prstGeom prst="rect">
             <a:avLst/>
@@ -9999,7 +11916,7 @@
           <a:p>
             <a:pPr algn="l"/>
             <a:r>
-              <a:rPr sz="1200" b="0" i="0">
+              <a:rPr sz="1500" b="0" i="0">
                 <a:solidFill>
                   <a:srgbClr val="555560"/>
                 </a:solidFill>
@@ -10012,7 +11929,7 @@
       </p:sp>
       <p:sp>
         <p:nvSpPr>
-          <p:cNvPr id="15" name="Rectangle 14"/>
+          <p:cNvPr id="17" name="Rectangle 16"/>
           <p:cNvSpPr/>
           <p:nvPr/>
         </p:nvSpPr>
@@ -10056,7 +11973,7 @@
       </p:sp>
       <p:sp>
         <p:nvSpPr>
-          <p:cNvPr id="16" name="Rectangle 15"/>
+          <p:cNvPr id="18" name="Rectangle 17"/>
           <p:cNvSpPr/>
           <p:nvPr/>
         </p:nvSpPr>
@@ -10069,7 +11986,7 @@
             <a:avLst/>
           </a:prstGeom>
           <a:solidFill>
-            <a:srgbClr val="115E59"/>
+            <a:srgbClr val="F0C840"/>
           </a:solidFill>
           <a:ln>
             <a:noFill/>
@@ -10100,14 +12017,14 @@
       </p:sp>
       <p:sp>
         <p:nvSpPr>
-          <p:cNvPr id="17" name="TextBox 16"/>
+          <p:cNvPr id="19" name="TextBox 18"/>
           <p:cNvSpPr txBox="1"/>
           <p:nvPr/>
         </p:nvSpPr>
         <p:spPr>
           <a:xfrm>
-            <a:off x="8351520" y="1289304"/>
-            <a:ext cx="3169920" cy="640080"/>
+            <a:off x="8442960" y="2761488"/>
+            <a:ext cx="2987040" cy="548640"/>
           </a:xfrm>
           <a:prstGeom prst="rect">
             <a:avLst/>
@@ -10122,7 +12039,7 @@
           <a:p>
             <a:pPr algn="l"/>
             <a:r>
-              <a:rPr sz="1500" b="1" i="0">
+              <a:rPr sz="1900" b="1" i="0">
                 <a:solidFill>
                   <a:srgbClr val="14141C"/>
                 </a:solidFill>
@@ -10135,14 +12052,58 @@
       </p:sp>
       <p:sp>
         <p:nvSpPr>
-          <p:cNvPr id="18" name="TextBox 17"/>
+          <p:cNvPr id="20" name="Rectangle 19"/>
+          <p:cNvSpPr/>
+          <p:nvPr/>
+        </p:nvSpPr>
+        <p:spPr>
+          <a:xfrm>
+            <a:off x="8461248" y="3346704"/>
+            <a:ext cx="658368" cy="32004"/>
+          </a:xfrm>
+          <a:prstGeom prst="rect">
+            <a:avLst/>
+          </a:prstGeom>
+          <a:solidFill>
+            <a:srgbClr val="F0C840"/>
+          </a:solidFill>
+          <a:ln>
+            <a:noFill/>
+          </a:ln>
+          <a:effectLst/>
+        </p:spPr>
+        <p:style>
+          <a:lnRef idx="1">
+            <a:schemeClr val="accent1"/>
+          </a:lnRef>
+          <a:fillRef idx="3">
+            <a:schemeClr val="accent1"/>
+          </a:fillRef>
+          <a:effectRef idx="2">
+            <a:schemeClr val="accent1"/>
+          </a:effectRef>
+          <a:fontRef idx="minor">
+            <a:schemeClr val="lt1"/>
+          </a:fontRef>
+        </p:style>
+        <p:txBody>
+          <a:bodyPr rtlCol="0" anchor="ctr"/>
+          <a:lstStyle/>
+          <a:p>
+            <a:pPr algn="ctr"/>
+          </a:p>
+        </p:txBody>
+      </p:sp>
+      <p:sp>
+        <p:nvSpPr>
+          <p:cNvPr id="21" name="TextBox 20"/>
           <p:cNvSpPr txBox="1"/>
           <p:nvPr/>
         </p:nvSpPr>
         <p:spPr>
           <a:xfrm>
-            <a:off x="8351520" y="2011680"/>
-            <a:ext cx="3169920" cy="4069079"/>
+            <a:off x="8442960" y="3547872"/>
+            <a:ext cx="2987040" cy="2606039"/>
           </a:xfrm>
           <a:prstGeom prst="rect">
             <a:avLst/>
@@ -10157,7 +12118,7 @@
           <a:p>
             <a:pPr algn="l"/>
             <a:r>
-              <a:rPr sz="1200" b="0" i="0">
+              <a:rPr sz="1500" b="0" i="0">
                 <a:solidFill>
                   <a:srgbClr val="555560"/>
                 </a:solidFill>
@@ -10447,7 +12408,7 @@
             <a:avLst/>
           </a:prstGeom>
           <a:solidFill>
-            <a:srgbClr val="9A3412"/>
+            <a:srgbClr val="40E0D0"/>
           </a:solidFill>
           <a:ln>
             <a:noFill/>
@@ -10484,8 +12445,8 @@
         </p:nvSpPr>
         <p:spPr>
           <a:xfrm>
-            <a:off x="640080" y="1289304"/>
-            <a:ext cx="3169920" cy="640080"/>
+            <a:off x="731520" y="2761488"/>
+            <a:ext cx="2987040" cy="548640"/>
           </a:xfrm>
           <a:prstGeom prst="rect">
             <a:avLst/>
@@ -10500,7 +12461,7 @@
           <a:p>
             <a:pPr algn="l"/>
             <a:r>
-              <a:rPr sz="1500" b="1" i="0">
+              <a:rPr sz="1900" b="1" i="0">
                 <a:solidFill>
                   <a:srgbClr val="14141C"/>
                 </a:solidFill>
@@ -10513,14 +12474,58 @@
       </p:sp>
       <p:sp>
         <p:nvSpPr>
-          <p:cNvPr id="10" name="TextBox 9"/>
+          <p:cNvPr id="10" name="Rectangle 9"/>
+          <p:cNvSpPr/>
+          <p:nvPr/>
+        </p:nvSpPr>
+        <p:spPr>
+          <a:xfrm>
+            <a:off x="749808" y="3346704"/>
+            <a:ext cx="658368" cy="32004"/>
+          </a:xfrm>
+          <a:prstGeom prst="rect">
+            <a:avLst/>
+          </a:prstGeom>
+          <a:solidFill>
+            <a:srgbClr val="40E0D0"/>
+          </a:solidFill>
+          <a:ln>
+            <a:noFill/>
+          </a:ln>
+          <a:effectLst/>
+        </p:spPr>
+        <p:style>
+          <a:lnRef idx="1">
+            <a:schemeClr val="accent1"/>
+          </a:lnRef>
+          <a:fillRef idx="3">
+            <a:schemeClr val="accent1"/>
+          </a:fillRef>
+          <a:effectRef idx="2">
+            <a:schemeClr val="accent1"/>
+          </a:effectRef>
+          <a:fontRef idx="minor">
+            <a:schemeClr val="lt1"/>
+          </a:fontRef>
+        </p:style>
+        <p:txBody>
+          <a:bodyPr rtlCol="0" anchor="ctr"/>
+          <a:lstStyle/>
+          <a:p>
+            <a:pPr algn="ctr"/>
+          </a:p>
+        </p:txBody>
+      </p:sp>
+      <p:sp>
+        <p:nvSpPr>
+          <p:cNvPr id="11" name="TextBox 10"/>
           <p:cNvSpPr txBox="1"/>
           <p:nvPr/>
         </p:nvSpPr>
         <p:spPr>
           <a:xfrm>
-            <a:off x="640080" y="2011680"/>
-            <a:ext cx="3169920" cy="4069079"/>
+            <a:off x="731520" y="3547872"/>
+            <a:ext cx="2987040" cy="2606039"/>
           </a:xfrm>
           <a:prstGeom prst="rect">
             <a:avLst/>
@@ -10535,7 +12540,7 @@
           <a:p>
             <a:pPr algn="l"/>
             <a:r>
-              <a:rPr sz="1200" b="0" i="0">
+              <a:rPr sz="1500" b="0" i="0">
                 <a:solidFill>
                   <a:srgbClr val="555560"/>
                 </a:solidFill>
@@ -10548,7 +12553,7 @@
       </p:sp>
       <p:sp>
         <p:nvSpPr>
-          <p:cNvPr id="11" name="Rectangle 10"/>
+          <p:cNvPr id="12" name="Rectangle 11"/>
           <p:cNvSpPr/>
           <p:nvPr/>
         </p:nvSpPr>
@@ -10592,7 +12597,7 @@
       </p:sp>
       <p:sp>
         <p:nvSpPr>
-          <p:cNvPr id="12" name="Rectangle 11"/>
+          <p:cNvPr id="13" name="Rectangle 12"/>
           <p:cNvSpPr/>
           <p:nvPr/>
         </p:nvSpPr>
@@ -10605,7 +12610,7 @@
             <a:avLst/>
           </a:prstGeom>
           <a:solidFill>
-            <a:srgbClr val="1E3A8A"/>
+            <a:srgbClr val="FF1493"/>
           </a:solidFill>
           <a:ln>
             <a:noFill/>
@@ -10636,14 +12641,14 @@
       </p:sp>
       <p:sp>
         <p:nvSpPr>
-          <p:cNvPr id="13" name="TextBox 12"/>
+          <p:cNvPr id="14" name="TextBox 13"/>
           <p:cNvSpPr txBox="1"/>
           <p:nvPr/>
         </p:nvSpPr>
         <p:spPr>
           <a:xfrm>
-            <a:off x="4495800" y="1289304"/>
-            <a:ext cx="3169920" cy="640080"/>
+            <a:off x="4587240" y="2761488"/>
+            <a:ext cx="2987040" cy="548640"/>
           </a:xfrm>
           <a:prstGeom prst="rect">
             <a:avLst/>
@@ -10658,7 +12663,7 @@
           <a:p>
             <a:pPr algn="l"/>
             <a:r>
-              <a:rPr sz="1500" b="1" i="0">
+              <a:rPr sz="1900" b="1" i="0">
                 <a:solidFill>
                   <a:srgbClr val="14141C"/>
                 </a:solidFill>
@@ -10671,14 +12676,58 @@
       </p:sp>
       <p:sp>
         <p:nvSpPr>
-          <p:cNvPr id="14" name="TextBox 13"/>
+          <p:cNvPr id="15" name="Rectangle 14"/>
+          <p:cNvSpPr/>
+          <p:nvPr/>
+        </p:nvSpPr>
+        <p:spPr>
+          <a:xfrm>
+            <a:off x="4605528" y="3346704"/>
+            <a:ext cx="658368" cy="32004"/>
+          </a:xfrm>
+          <a:prstGeom prst="rect">
+            <a:avLst/>
+          </a:prstGeom>
+          <a:solidFill>
+            <a:srgbClr val="FF1493"/>
+          </a:solidFill>
+          <a:ln>
+            <a:noFill/>
+          </a:ln>
+          <a:effectLst/>
+        </p:spPr>
+        <p:style>
+          <a:lnRef idx="1">
+            <a:schemeClr val="accent1"/>
+          </a:lnRef>
+          <a:fillRef idx="3">
+            <a:schemeClr val="accent1"/>
+          </a:fillRef>
+          <a:effectRef idx="2">
+            <a:schemeClr val="accent1"/>
+          </a:effectRef>
+          <a:fontRef idx="minor">
+            <a:schemeClr val="lt1"/>
+          </a:fontRef>
+        </p:style>
+        <p:txBody>
+          <a:bodyPr rtlCol="0" anchor="ctr"/>
+          <a:lstStyle/>
+          <a:p>
+            <a:pPr algn="ctr"/>
+          </a:p>
+        </p:txBody>
+      </p:sp>
+      <p:sp>
+        <p:nvSpPr>
+          <p:cNvPr id="16" name="TextBox 15"/>
           <p:cNvSpPr txBox="1"/>
           <p:nvPr/>
         </p:nvSpPr>
         <p:spPr>
           <a:xfrm>
-            <a:off x="4495800" y="2011680"/>
-            <a:ext cx="3169920" cy="4069079"/>
+            <a:off x="4587240" y="3547872"/>
+            <a:ext cx="2987040" cy="2606039"/>
           </a:xfrm>
           <a:prstGeom prst="rect">
             <a:avLst/>
@@ -10693,7 +12742,7 @@
           <a:p>
             <a:pPr algn="l"/>
             <a:r>
-              <a:rPr sz="1200" b="0" i="0">
+              <a:rPr sz="1500" b="0" i="0">
                 <a:solidFill>
                   <a:srgbClr val="555560"/>
                 </a:solidFill>
@@ -10706,7 +12755,7 @@
       </p:sp>
       <p:sp>
         <p:nvSpPr>
-          <p:cNvPr id="15" name="Rectangle 14"/>
+          <p:cNvPr id="17" name="Rectangle 16"/>
           <p:cNvSpPr/>
           <p:nvPr/>
         </p:nvSpPr>
@@ -10750,7 +12799,7 @@
       </p:sp>
       <p:sp>
         <p:nvSpPr>
-          <p:cNvPr id="16" name="Rectangle 15"/>
+          <p:cNvPr id="18" name="Rectangle 17"/>
           <p:cNvSpPr/>
           <p:nvPr/>
         </p:nvSpPr>
@@ -10763,7 +12812,7 @@
             <a:avLst/>
           </a:prstGeom>
           <a:solidFill>
-            <a:srgbClr val="115E59"/>
+            <a:srgbClr val="F0C840"/>
           </a:solidFill>
           <a:ln>
             <a:noFill/>
@@ -10794,14 +12843,14 @@
       </p:sp>
       <p:sp>
         <p:nvSpPr>
-          <p:cNvPr id="17" name="TextBox 16"/>
+          <p:cNvPr id="19" name="TextBox 18"/>
           <p:cNvSpPr txBox="1"/>
           <p:nvPr/>
         </p:nvSpPr>
         <p:spPr>
           <a:xfrm>
-            <a:off x="8351520" y="1289304"/>
-            <a:ext cx="3169920" cy="640080"/>
+            <a:off x="8442960" y="2761488"/>
+            <a:ext cx="2987040" cy="548640"/>
           </a:xfrm>
           <a:prstGeom prst="rect">
             <a:avLst/>
@@ -10816,7 +12865,7 @@
           <a:p>
             <a:pPr algn="l"/>
             <a:r>
-              <a:rPr sz="1500" b="1" i="0">
+              <a:rPr sz="1900" b="1" i="0">
                 <a:solidFill>
                   <a:srgbClr val="14141C"/>
                 </a:solidFill>
@@ -10829,14 +12878,58 @@
       </p:sp>
       <p:sp>
         <p:nvSpPr>
-          <p:cNvPr id="18" name="TextBox 17"/>
+          <p:cNvPr id="20" name="Rectangle 19"/>
+          <p:cNvSpPr/>
+          <p:nvPr/>
+        </p:nvSpPr>
+        <p:spPr>
+          <a:xfrm>
+            <a:off x="8461248" y="3346704"/>
+            <a:ext cx="658368" cy="32004"/>
+          </a:xfrm>
+          <a:prstGeom prst="rect">
+            <a:avLst/>
+          </a:prstGeom>
+          <a:solidFill>
+            <a:srgbClr val="F0C840"/>
+          </a:solidFill>
+          <a:ln>
+            <a:noFill/>
+          </a:ln>
+          <a:effectLst/>
+        </p:spPr>
+        <p:style>
+          <a:lnRef idx="1">
+            <a:schemeClr val="accent1"/>
+          </a:lnRef>
+          <a:fillRef idx="3">
+            <a:schemeClr val="accent1"/>
+          </a:fillRef>
+          <a:effectRef idx="2">
+            <a:schemeClr val="accent1"/>
+          </a:effectRef>
+          <a:fontRef idx="minor">
+            <a:schemeClr val="lt1"/>
+          </a:fontRef>
+        </p:style>
+        <p:txBody>
+          <a:bodyPr rtlCol="0" anchor="ctr"/>
+          <a:lstStyle/>
+          <a:p>
+            <a:pPr algn="ctr"/>
+          </a:p>
+        </p:txBody>
+      </p:sp>
+      <p:sp>
+        <p:nvSpPr>
+          <p:cNvPr id="21" name="TextBox 20"/>
           <p:cNvSpPr txBox="1"/>
           <p:nvPr/>
         </p:nvSpPr>
         <p:spPr>
           <a:xfrm>
-            <a:off x="8351520" y="2011680"/>
-            <a:ext cx="3169920" cy="4069079"/>
+            <a:off x="8442960" y="3547872"/>
+            <a:ext cx="2987040" cy="2606039"/>
           </a:xfrm>
           <a:prstGeom prst="rect">
             <a:avLst/>
@@ -10851,7 +12944,7 @@
           <a:p>
             <a:pPr algn="l"/>
             <a:r>
-              <a:rPr sz="1200" b="0" i="0">
+              <a:rPr sz="1500" b="0" i="0">
                 <a:solidFill>
                   <a:srgbClr val="555560"/>
                 </a:solidFill>
@@ -11649,8 +13742,8 @@
         </p:nvSpPr>
         <p:spPr>
           <a:xfrm>
-            <a:off x="7322515" y="1389888"/>
-            <a:ext cx="91440" cy="91440"/>
+            <a:off x="7340803" y="3154680"/>
+            <a:ext cx="100584" cy="100584"/>
           </a:xfrm>
           <a:prstGeom prst="rect">
             <a:avLst/>
@@ -11693,8 +13786,8 @@
         </p:nvSpPr>
         <p:spPr>
           <a:xfrm>
-            <a:off x="7523683" y="1325880"/>
-            <a:ext cx="4016044" cy="2020824"/>
+            <a:off x="7560259" y="1325880"/>
+            <a:ext cx="3942892" cy="4571999"/>
           </a:xfrm>
           <a:prstGeom prst="rect">
             <a:avLst/>
@@ -11702,14 +13795,14 @@
           <a:noFill/>
         </p:spPr>
         <p:txBody>
-          <a:bodyPr wrap="square" anchor="t" lIns="0" rIns="0" tIns="0" bIns="0">
+          <a:bodyPr wrap="square" anchor="ctr" lIns="0" rIns="0" tIns="0" bIns="0">
             <a:spAutoFit/>
           </a:bodyPr>
           <a:lstStyle/>
           <a:p>
             <a:pPr algn="l"/>
             <a:r>
-              <a:rPr sz="1300" b="0" i="0">
+              <a:rPr sz="1500" b="0" i="0">
                 <a:solidFill>
                   <a:srgbClr val="14141C"/>
                 </a:solidFill>
@@ -12046,4 +14139,324 @@
   </a:objectDefaults>
   <a:extraClrSchemeLst/>
 </a:theme>
+</file>
+
+<file path=ppt/theme/theme2.xml><?xml version="1.0" encoding="utf-8"?>
+<a:theme xmlns:a="http://schemas.openxmlformats.org/drawingml/2006/main" name="Office Theme">
+  <a:themeElements>
+    <a:clrScheme name="Office">
+      <a:dk1>
+        <a:sysClr val="windowText" lastClr="000000"/>
+      </a:dk1>
+      <a:lt1>
+        <a:sysClr val="window" lastClr="FFFFFF"/>
+      </a:lt1>
+      <a:dk2>
+        <a:srgbClr val="1F497D"/>
+      </a:dk2>
+      <a:lt2>
+        <a:srgbClr val="EEECE1"/>
+      </a:lt2>
+      <a:accent1>
+        <a:srgbClr val="4F81BD"/>
+      </a:accent1>
+      <a:accent2>
+        <a:srgbClr val="C0504D"/>
+      </a:accent2>
+      <a:accent3>
+        <a:srgbClr val="9BBB59"/>
+      </a:accent3>
+      <a:accent4>
+        <a:srgbClr val="8064A2"/>
+      </a:accent4>
+      <a:accent5>
+        <a:srgbClr val="4BACC6"/>
+      </a:accent5>
+      <a:accent6>
+        <a:srgbClr val="F79646"/>
+      </a:accent6>
+      <a:hlink>
+        <a:srgbClr val="0000FF"/>
+      </a:hlink>
+      <a:folHlink>
+        <a:srgbClr val="800080"/>
+      </a:folHlink>
+    </a:clrScheme>
+    <a:fontScheme name="Office">
+      <a:majorFont>
+        <a:latin typeface="Calibri"/>
+        <a:ea typeface=""/>
+        <a:cs typeface=""/>
+        <a:font script="Jpan" typeface="ＭＳ Ｐゴシック"/>
+        <a:font script="Hang" typeface="맑은 고딕"/>
+        <a:font script="Hans" typeface="宋体"/>
+        <a:font script="Hant" typeface="新細明體"/>
+        <a:font script="Arab" typeface="Times New Roman"/>
+        <a:font script="Hebr" typeface="Times New Roman"/>
+        <a:font script="Thai" typeface="Angsana New"/>
+        <a:font script="Ethi" typeface="Nyala"/>
+        <a:font script="Beng" typeface="Vrinda"/>
+        <a:font script="Gujr" typeface="Shruti"/>
+        <a:font script="Khmr" typeface="MoolBoran"/>
+        <a:font script="Knda" typeface="Tunga"/>
+        <a:font script="Guru" typeface="Raavi"/>
+        <a:font script="Cans" typeface="Euphemia"/>
+        <a:font script="Cher" typeface="Plantagenet Cherokee"/>
+        <a:font script="Yiii" typeface="Microsoft Yi Baiti"/>
+        <a:font script="Tibt" typeface="Microsoft Himalaya"/>
+        <a:font script="Thaa" typeface="MV Boli"/>
+        <a:font script="Deva" typeface="Mangal"/>
+        <a:font script="Telu" typeface="Gautami"/>
+        <a:font script="Taml" typeface="Latha"/>
+        <a:font script="Syrc" typeface="Estrangelo Edessa"/>
+        <a:font script="Orya" typeface="Kalinga"/>
+        <a:font script="Mlym" typeface="Kartika"/>
+        <a:font script="Laoo" typeface="DokChampa"/>
+        <a:font script="Sinh" typeface="Iskoola Pota"/>
+        <a:font script="Mong" typeface="Mongolian Baiti"/>
+        <a:font script="Viet" typeface="Times New Roman"/>
+        <a:font script="Uigh" typeface="Microsoft Uighur"/>
+        <a:font script="Geor" typeface="Sylfaen"/>
+      </a:majorFont>
+      <a:minorFont>
+        <a:latin typeface="Calibri"/>
+        <a:ea typeface=""/>
+        <a:cs typeface=""/>
+        <a:font script="Jpan" typeface="ＭＳ Ｐゴシック"/>
+        <a:font script="Hang" typeface="맑은 고딕"/>
+        <a:font script="Hans" typeface="宋体"/>
+        <a:font script="Hant" typeface="新細明體"/>
+        <a:font script="Arab" typeface="Arial"/>
+        <a:font script="Hebr" typeface="Arial"/>
+        <a:font script="Thai" typeface="Cordia New"/>
+        <a:font script="Ethi" typeface="Nyala"/>
+        <a:font script="Beng" typeface="Vrinda"/>
+        <a:font script="Gujr" typeface="Shruti"/>
+        <a:font script="Khmr" typeface="DaunPenh"/>
+        <a:font script="Knda" typeface="Tunga"/>
+        <a:font script="Guru" typeface="Raavi"/>
+        <a:font script="Cans" typeface="Euphemia"/>
+        <a:font script="Cher" typeface="Plantagenet Cherokee"/>
+        <a:font script="Yiii" typeface="Microsoft Yi Baiti"/>
+        <a:font script="Tibt" typeface="Microsoft Himalaya"/>
+        <a:font script="Thaa" typeface="MV Boli"/>
+        <a:font script="Deva" typeface="Mangal"/>
+        <a:font script="Telu" typeface="Gautami"/>
+        <a:font script="Taml" typeface="Latha"/>
+        <a:font script="Syrc" typeface="Estrangelo Edessa"/>
+        <a:font script="Orya" typeface="Kalinga"/>
+        <a:font script="Mlym" typeface="Kartika"/>
+        <a:font script="Laoo" typeface="DokChampa"/>
+        <a:font script="Sinh" typeface="Iskoola Pota"/>
+        <a:font script="Mong" typeface="Mongolian Baiti"/>
+        <a:font script="Viet" typeface="Arial"/>
+        <a:font script="Uigh" typeface="Microsoft Uighur"/>
+        <a:font script="Geor" typeface="Sylfaen"/>
+      </a:minorFont>
+    </a:fontScheme>
+    <a:fmtScheme name="Office">
+      <a:fillStyleLst>
+        <a:solidFill>
+          <a:schemeClr val="phClr"/>
+        </a:solidFill>
+        <a:gradFill rotWithShape="1">
+          <a:gsLst>
+            <a:gs pos="0">
+              <a:schemeClr val="phClr">
+                <a:tint val="50000"/>
+                <a:satMod val="300000"/>
+              </a:schemeClr>
+            </a:gs>
+            <a:gs pos="35000">
+              <a:schemeClr val="phClr">
+                <a:tint val="37000"/>
+                <a:satMod val="300000"/>
+              </a:schemeClr>
+            </a:gs>
+            <a:gs pos="100000">
+              <a:schemeClr val="phClr">
+                <a:tint val="15000"/>
+                <a:satMod val="350000"/>
+              </a:schemeClr>
+            </a:gs>
+          </a:gsLst>
+          <a:lin ang="16200000" scaled="1"/>
+        </a:gradFill>
+        <a:gradFill rotWithShape="1">
+          <a:gsLst>
+            <a:gs pos="0">
+              <a:schemeClr val="phClr">
+                <a:tint val="100000"/>
+                <a:shade val="100000"/>
+                <a:satMod val="130000"/>
+              </a:schemeClr>
+            </a:gs>
+            <a:gs pos="100000">
+              <a:schemeClr val="phClr">
+                <a:tint val="50000"/>
+                <a:shade val="100000"/>
+                <a:satMod val="350000"/>
+              </a:schemeClr>
+            </a:gs>
+          </a:gsLst>
+          <a:lin ang="16200000" scaled="0"/>
+        </a:gradFill>
+      </a:fillStyleLst>
+      <a:lnStyleLst>
+        <a:ln w="9525" cap="flat" cmpd="sng" algn="ctr">
+          <a:solidFill>
+            <a:schemeClr val="phClr">
+              <a:shade val="95000"/>
+              <a:satMod val="105000"/>
+            </a:schemeClr>
+          </a:solidFill>
+          <a:prstDash val="solid"/>
+        </a:ln>
+        <a:ln w="25400" cap="flat" cmpd="sng" algn="ctr">
+          <a:solidFill>
+            <a:schemeClr val="phClr"/>
+          </a:solidFill>
+          <a:prstDash val="solid"/>
+        </a:ln>
+        <a:ln w="38100" cap="flat" cmpd="sng" algn="ctr">
+          <a:solidFill>
+            <a:schemeClr val="phClr"/>
+          </a:solidFill>
+          <a:prstDash val="solid"/>
+        </a:ln>
+      </a:lnStyleLst>
+      <a:effectStyleLst>
+        <a:effectStyle>
+          <a:effectLst>
+            <a:outerShdw blurRad="40000" dist="20000" dir="5400000" rotWithShape="0">
+              <a:srgbClr val="000000">
+                <a:alpha val="38000"/>
+              </a:srgbClr>
+            </a:outerShdw>
+          </a:effectLst>
+        </a:effectStyle>
+        <a:effectStyle>
+          <a:effectLst>
+            <a:outerShdw blurRad="40000" dist="23000" dir="5400000" rotWithShape="0">
+              <a:srgbClr val="000000">
+                <a:alpha val="35000"/>
+              </a:srgbClr>
+            </a:outerShdw>
+          </a:effectLst>
+        </a:effectStyle>
+        <a:effectStyle>
+          <a:effectLst>
+            <a:outerShdw blurRad="40000" dist="23000" dir="5400000" rotWithShape="0">
+              <a:srgbClr val="000000">
+                <a:alpha val="35000"/>
+              </a:srgbClr>
+            </a:outerShdw>
+          </a:effectLst>
+          <a:scene3d>
+            <a:camera prst="orthographicFront">
+              <a:rot lat="0" lon="0" rev="0"/>
+            </a:camera>
+            <a:lightRig rig="threePt" dir="t">
+              <a:rot lat="0" lon="0" rev="1200000"/>
+            </a:lightRig>
+          </a:scene3d>
+          <a:sp3d>
+            <a:bevelT w="63500" h="25400"/>
+          </a:sp3d>
+        </a:effectStyle>
+      </a:effectStyleLst>
+      <a:bgFillStyleLst>
+        <a:solidFill>
+          <a:schemeClr val="phClr"/>
+        </a:solidFill>
+        <a:gradFill rotWithShape="1">
+          <a:gsLst>
+            <a:gs pos="0">
+              <a:schemeClr val="phClr">
+                <a:tint val="40000"/>
+                <a:satMod val="350000"/>
+              </a:schemeClr>
+            </a:gs>
+            <a:gs pos="40000">
+              <a:schemeClr val="phClr">
+                <a:tint val="45000"/>
+                <a:shade val="99000"/>
+                <a:satMod val="350000"/>
+              </a:schemeClr>
+            </a:gs>
+            <a:gs pos="100000">
+              <a:schemeClr val="phClr">
+                <a:shade val="20000"/>
+                <a:satMod val="255000"/>
+              </a:schemeClr>
+            </a:gs>
+          </a:gsLst>
+          <a:path path="circle">
+            <a:fillToRect l="50000" t="-80000" r="50000" b="180000"/>
+          </a:path>
+        </a:gradFill>
+        <a:gradFill rotWithShape="1">
+          <a:gsLst>
+            <a:gs pos="0">
+              <a:schemeClr val="phClr">
+                <a:tint val="80000"/>
+                <a:satMod val="300000"/>
+              </a:schemeClr>
+            </a:gs>
+            <a:gs pos="100000">
+              <a:schemeClr val="phClr">
+                <a:shade val="30000"/>
+                <a:satMod val="200000"/>
+              </a:schemeClr>
+            </a:gs>
+          </a:gsLst>
+          <a:path path="circle">
+            <a:fillToRect l="50000" t="50000" r="50000" b="50000"/>
+          </a:path>
+        </a:gradFill>
+      </a:bgFillStyleLst>
+    </a:fmtScheme>
+  </a:themeElements>
+  <a:objectDefaults>
+    <a:spDef>
+      <a:spPr/>
+      <a:bodyPr/>
+      <a:lstStyle/>
+      <a:style>
+        <a:lnRef idx="1">
+          <a:schemeClr val="accent1"/>
+        </a:lnRef>
+        <a:fillRef idx="3">
+          <a:schemeClr val="accent1"/>
+        </a:fillRef>
+        <a:effectRef idx="2">
+          <a:schemeClr val="accent1"/>
+        </a:effectRef>
+        <a:fontRef idx="minor">
+          <a:schemeClr val="lt1"/>
+        </a:fontRef>
+      </a:style>
+    </a:spDef>
+    <a:lnDef>
+      <a:spPr/>
+      <a:bodyPr/>
+      <a:lstStyle/>
+      <a:style>
+        <a:lnRef idx="2">
+          <a:schemeClr val="accent1"/>
+        </a:lnRef>
+        <a:fillRef idx="0">
+          <a:schemeClr val="accent1"/>
+        </a:fillRef>
+        <a:effectRef idx="1">
+          <a:schemeClr val="accent1"/>
+        </a:effectRef>
+        <a:fontRef idx="minor">
+          <a:schemeClr val="tx1"/>
+        </a:fontRef>
+      </a:style>
+    </a:lnDef>
+  </a:objectDefaults>
+  <a:extraClrSchemeLst/>
+</a:theme>
 </file>
</xml_diff>